<commit_message>
chore: initial repository scaffolding and PBL documentation
</commit_message>
<xml_diff>
--- a/submission_reports/DocuQuery_AI_Presentation.pptx
+++ b/submission_reports/DocuQuery_AI_Presentation.pptx
@@ -143,7 +143,7 @@
           <p:cNvPr id="2" name="Title 1">
             <a:extLst>
               <a:ext uri="{FF2B5EF4-FFF2-40B4-BE49-F238E27FC236}">
-                <a16:creationId xmlns:a16="http://schemas.microsoft.com/office/drawing/2014/main" id="{3E298067-E3FF-B953-10B5-2FAAED199BB5}"/>
+                <a16:creationId xmlns:a16="http://schemas.microsoft.com/office/drawing/2014/main" id="{65378E3E-E93D-B2FA-3FDA-6F2C2B8C04BB}"/>
               </a:ext>
             </a:extLst>
           </p:cNvPr>
@@ -181,7 +181,7 @@
           <p:cNvPr id="3" name="Subtitle 2">
             <a:extLst>
               <a:ext uri="{FF2B5EF4-FFF2-40B4-BE49-F238E27FC236}">
-                <a16:creationId xmlns:a16="http://schemas.microsoft.com/office/drawing/2014/main" id="{14D34A2B-9D78-08C8-D321-6E6DB222A8CE}"/>
+                <a16:creationId xmlns:a16="http://schemas.microsoft.com/office/drawing/2014/main" id="{2F56DEAD-5195-B802-1225-41276CDB7F15}"/>
               </a:ext>
             </a:extLst>
           </p:cNvPr>
@@ -252,7 +252,7 @@
           <p:cNvPr id="4" name="Date Placeholder 3">
             <a:extLst>
               <a:ext uri="{FF2B5EF4-FFF2-40B4-BE49-F238E27FC236}">
-                <a16:creationId xmlns:a16="http://schemas.microsoft.com/office/drawing/2014/main" id="{D5BA4338-B731-67FA-5675-CE6B5EBC09D1}"/>
+                <a16:creationId xmlns:a16="http://schemas.microsoft.com/office/drawing/2014/main" id="{45CF4CFE-8B97-83D2-3961-700F8387714D}"/>
               </a:ext>
             </a:extLst>
           </p:cNvPr>
@@ -268,7 +268,7 @@
           <a:bodyPr/>
           <a:lstStyle/>
           <a:p>
-            <a:fld id="{3EF7019B-3CBE-473F-A852-41B4E9884D2B}" type="datetimeFigureOut">
+            <a:fld id="{CF59C9E7-27AD-49B0-9749-76DA7CA1A074}" type="datetimeFigureOut">
               <a:rPr lang="en-IN" smtClean="0"/>
               <a:t>13-10-2026</a:t>
             </a:fld>
@@ -281,7 +281,7 @@
           <p:cNvPr id="5" name="Footer Placeholder 4">
             <a:extLst>
               <a:ext uri="{FF2B5EF4-FFF2-40B4-BE49-F238E27FC236}">
-                <a16:creationId xmlns:a16="http://schemas.microsoft.com/office/drawing/2014/main" id="{997AD0AA-4AE4-D4B1-099C-44A971BF5F59}"/>
+                <a16:creationId xmlns:a16="http://schemas.microsoft.com/office/drawing/2014/main" id="{EDFE043F-4B2C-A509-DBED-D6D97843A863}"/>
               </a:ext>
             </a:extLst>
           </p:cNvPr>
@@ -306,7 +306,7 @@
           <p:cNvPr id="6" name="Slide Number Placeholder 5">
             <a:extLst>
               <a:ext uri="{FF2B5EF4-FFF2-40B4-BE49-F238E27FC236}">
-                <a16:creationId xmlns:a16="http://schemas.microsoft.com/office/drawing/2014/main" id="{F6CC769D-2617-C747-8541-8275C964A992}"/>
+                <a16:creationId xmlns:a16="http://schemas.microsoft.com/office/drawing/2014/main" id="{11AA633B-D72A-40B1-4824-717CF5200159}"/>
               </a:ext>
             </a:extLst>
           </p:cNvPr>
@@ -322,7 +322,7 @@
           <a:bodyPr/>
           <a:lstStyle/>
           <a:p>
-            <a:fld id="{6E7CDEDE-B9A9-4A26-AEA8-F99C5C25440B}" type="slidenum">
+            <a:fld id="{A9C1A5ED-373C-43E3-A30A-7C89C8477F1A}" type="slidenum">
               <a:rPr lang="en-IN" smtClean="0"/>
               <a:t>‹#›</a:t>
             </a:fld>
@@ -333,7 +333,7 @@
     </p:spTree>
     <p:extLst>
       <p:ext uri="{BB962C8B-B14F-4D97-AF65-F5344CB8AC3E}">
-        <p14:creationId xmlns:p14="http://schemas.microsoft.com/office/powerpoint/2010/main" val="1731622806"/>
+        <p14:creationId xmlns:p14="http://schemas.microsoft.com/office/powerpoint/2010/main" val="2917462052"/>
       </p:ext>
     </p:extLst>
   </p:cSld>
@@ -365,7 +365,7 @@
           <p:cNvPr id="2" name="Title 1">
             <a:extLst>
               <a:ext uri="{FF2B5EF4-FFF2-40B4-BE49-F238E27FC236}">
-                <a16:creationId xmlns:a16="http://schemas.microsoft.com/office/drawing/2014/main" id="{60D4241E-5BB4-5C9A-9B8A-008DB7EDB27E}"/>
+                <a16:creationId xmlns:a16="http://schemas.microsoft.com/office/drawing/2014/main" id="{1B3AD81D-E407-A78A-1DEA-1B46AA6579A1}"/>
               </a:ext>
             </a:extLst>
           </p:cNvPr>
@@ -394,7 +394,7 @@
           <p:cNvPr id="3" name="Vertical Text Placeholder 2">
             <a:extLst>
               <a:ext uri="{FF2B5EF4-FFF2-40B4-BE49-F238E27FC236}">
-                <a16:creationId xmlns:a16="http://schemas.microsoft.com/office/drawing/2014/main" id="{0AD9D6AD-B70B-08DD-A8D6-AFC66E88FEBE}"/>
+                <a16:creationId xmlns:a16="http://schemas.microsoft.com/office/drawing/2014/main" id="{62223541-48A7-C593-BA53-E9D12B9701E6}"/>
               </a:ext>
             </a:extLst>
           </p:cNvPr>
@@ -452,7 +452,7 @@
           <p:cNvPr id="4" name="Date Placeholder 3">
             <a:extLst>
               <a:ext uri="{FF2B5EF4-FFF2-40B4-BE49-F238E27FC236}">
-                <a16:creationId xmlns:a16="http://schemas.microsoft.com/office/drawing/2014/main" id="{D06BA1F6-FFBF-D60B-BC84-FC0219904D67}"/>
+                <a16:creationId xmlns:a16="http://schemas.microsoft.com/office/drawing/2014/main" id="{287E3FF3-6969-D1C6-37F8-39794C0973DF}"/>
               </a:ext>
             </a:extLst>
           </p:cNvPr>
@@ -468,7 +468,7 @@
           <a:bodyPr/>
           <a:lstStyle/>
           <a:p>
-            <a:fld id="{3EF7019B-3CBE-473F-A852-41B4E9884D2B}" type="datetimeFigureOut">
+            <a:fld id="{CF59C9E7-27AD-49B0-9749-76DA7CA1A074}" type="datetimeFigureOut">
               <a:rPr lang="en-IN" smtClean="0"/>
               <a:t>13-10-2026</a:t>
             </a:fld>
@@ -481,7 +481,7 @@
           <p:cNvPr id="5" name="Footer Placeholder 4">
             <a:extLst>
               <a:ext uri="{FF2B5EF4-FFF2-40B4-BE49-F238E27FC236}">
-                <a16:creationId xmlns:a16="http://schemas.microsoft.com/office/drawing/2014/main" id="{1D030C77-4882-268B-A914-4664E642155A}"/>
+                <a16:creationId xmlns:a16="http://schemas.microsoft.com/office/drawing/2014/main" id="{0960DF53-2B6A-9385-AFE5-12A0E10ECBAB}"/>
               </a:ext>
             </a:extLst>
           </p:cNvPr>
@@ -506,7 +506,7 @@
           <p:cNvPr id="6" name="Slide Number Placeholder 5">
             <a:extLst>
               <a:ext uri="{FF2B5EF4-FFF2-40B4-BE49-F238E27FC236}">
-                <a16:creationId xmlns:a16="http://schemas.microsoft.com/office/drawing/2014/main" id="{A9ED1BF1-6720-9356-81CB-B8D1F38ED260}"/>
+                <a16:creationId xmlns:a16="http://schemas.microsoft.com/office/drawing/2014/main" id="{30C04257-1BEC-4FD7-9AEA-7B7DBD0EB3CA}"/>
               </a:ext>
             </a:extLst>
           </p:cNvPr>
@@ -522,7 +522,7 @@
           <a:bodyPr/>
           <a:lstStyle/>
           <a:p>
-            <a:fld id="{6E7CDEDE-B9A9-4A26-AEA8-F99C5C25440B}" type="slidenum">
+            <a:fld id="{A9C1A5ED-373C-43E3-A30A-7C89C8477F1A}" type="slidenum">
               <a:rPr lang="en-IN" smtClean="0"/>
               <a:t>‹#›</a:t>
             </a:fld>
@@ -533,7 +533,7 @@
     </p:spTree>
     <p:extLst>
       <p:ext uri="{BB962C8B-B14F-4D97-AF65-F5344CB8AC3E}">
-        <p14:creationId xmlns:p14="http://schemas.microsoft.com/office/powerpoint/2010/main" val="2189952053"/>
+        <p14:creationId xmlns:p14="http://schemas.microsoft.com/office/powerpoint/2010/main" val="140461122"/>
       </p:ext>
     </p:extLst>
   </p:cSld>
@@ -565,7 +565,7 @@
           <p:cNvPr id="2" name="Vertical Title 1">
             <a:extLst>
               <a:ext uri="{FF2B5EF4-FFF2-40B4-BE49-F238E27FC236}">
-                <a16:creationId xmlns:a16="http://schemas.microsoft.com/office/drawing/2014/main" id="{D2CCB327-50D6-DB44-6742-6A17DE653957}"/>
+                <a16:creationId xmlns:a16="http://schemas.microsoft.com/office/drawing/2014/main" id="{57B66E91-C5A6-64C7-78BD-DA3F8EC4F653}"/>
               </a:ext>
             </a:extLst>
           </p:cNvPr>
@@ -599,7 +599,7 @@
           <p:cNvPr id="3" name="Vertical Text Placeholder 2">
             <a:extLst>
               <a:ext uri="{FF2B5EF4-FFF2-40B4-BE49-F238E27FC236}">
-                <a16:creationId xmlns:a16="http://schemas.microsoft.com/office/drawing/2014/main" id="{CECC77E9-BF7F-6650-B190-F337B0C56529}"/>
+                <a16:creationId xmlns:a16="http://schemas.microsoft.com/office/drawing/2014/main" id="{7EFBB2CC-99BE-6709-9FD2-D26DB60D5BC5}"/>
               </a:ext>
             </a:extLst>
           </p:cNvPr>
@@ -662,7 +662,7 @@
           <p:cNvPr id="4" name="Date Placeholder 3">
             <a:extLst>
               <a:ext uri="{FF2B5EF4-FFF2-40B4-BE49-F238E27FC236}">
-                <a16:creationId xmlns:a16="http://schemas.microsoft.com/office/drawing/2014/main" id="{54F50042-F6F2-EBFD-688D-C82264A04742}"/>
+                <a16:creationId xmlns:a16="http://schemas.microsoft.com/office/drawing/2014/main" id="{90D9CE7D-0D11-87B9-4454-F74DBEC714BE}"/>
               </a:ext>
             </a:extLst>
           </p:cNvPr>
@@ -678,7 +678,7 @@
           <a:bodyPr/>
           <a:lstStyle/>
           <a:p>
-            <a:fld id="{3EF7019B-3CBE-473F-A852-41B4E9884D2B}" type="datetimeFigureOut">
+            <a:fld id="{CF59C9E7-27AD-49B0-9749-76DA7CA1A074}" type="datetimeFigureOut">
               <a:rPr lang="en-IN" smtClean="0"/>
               <a:t>13-10-2026</a:t>
             </a:fld>
@@ -691,7 +691,7 @@
           <p:cNvPr id="5" name="Footer Placeholder 4">
             <a:extLst>
               <a:ext uri="{FF2B5EF4-FFF2-40B4-BE49-F238E27FC236}">
-                <a16:creationId xmlns:a16="http://schemas.microsoft.com/office/drawing/2014/main" id="{1653B73F-4894-A01A-79E5-8DE0112B5BB5}"/>
+                <a16:creationId xmlns:a16="http://schemas.microsoft.com/office/drawing/2014/main" id="{B95639A6-0D2D-73DD-30B2-25F23A22D4B5}"/>
               </a:ext>
             </a:extLst>
           </p:cNvPr>
@@ -716,7 +716,7 @@
           <p:cNvPr id="6" name="Slide Number Placeholder 5">
             <a:extLst>
               <a:ext uri="{FF2B5EF4-FFF2-40B4-BE49-F238E27FC236}">
-                <a16:creationId xmlns:a16="http://schemas.microsoft.com/office/drawing/2014/main" id="{3CA8FA45-524F-494F-77C0-807C75678876}"/>
+                <a16:creationId xmlns:a16="http://schemas.microsoft.com/office/drawing/2014/main" id="{EBFACC9D-BB59-89B7-220D-FDFF6ADA2DAF}"/>
               </a:ext>
             </a:extLst>
           </p:cNvPr>
@@ -732,7 +732,7 @@
           <a:bodyPr/>
           <a:lstStyle/>
           <a:p>
-            <a:fld id="{6E7CDEDE-B9A9-4A26-AEA8-F99C5C25440B}" type="slidenum">
+            <a:fld id="{A9C1A5ED-373C-43E3-A30A-7C89C8477F1A}" type="slidenum">
               <a:rPr lang="en-IN" smtClean="0"/>
               <a:t>‹#›</a:t>
             </a:fld>
@@ -743,7 +743,7 @@
     </p:spTree>
     <p:extLst>
       <p:ext uri="{BB962C8B-B14F-4D97-AF65-F5344CB8AC3E}">
-        <p14:creationId xmlns:p14="http://schemas.microsoft.com/office/powerpoint/2010/main" val="3672138777"/>
+        <p14:creationId xmlns:p14="http://schemas.microsoft.com/office/powerpoint/2010/main" val="2780672961"/>
       </p:ext>
     </p:extLst>
   </p:cSld>
@@ -775,7 +775,7 @@
           <p:cNvPr id="2" name="Title 1">
             <a:extLst>
               <a:ext uri="{FF2B5EF4-FFF2-40B4-BE49-F238E27FC236}">
-                <a16:creationId xmlns:a16="http://schemas.microsoft.com/office/drawing/2014/main" id="{43279ADB-CE60-02AA-7054-BE1EA6A68EE9}"/>
+                <a16:creationId xmlns:a16="http://schemas.microsoft.com/office/drawing/2014/main" id="{CDE436F1-4A0A-8102-0DEF-6ED384898B08}"/>
               </a:ext>
             </a:extLst>
           </p:cNvPr>
@@ -804,7 +804,7 @@
           <p:cNvPr id="3" name="Content Placeholder 2">
             <a:extLst>
               <a:ext uri="{FF2B5EF4-FFF2-40B4-BE49-F238E27FC236}">
-                <a16:creationId xmlns:a16="http://schemas.microsoft.com/office/drawing/2014/main" id="{6423CE79-E202-A9C6-6B46-14425F951251}"/>
+                <a16:creationId xmlns:a16="http://schemas.microsoft.com/office/drawing/2014/main" id="{404CA76D-20B3-FE2E-B7C7-45D11E9D7032}"/>
               </a:ext>
             </a:extLst>
           </p:cNvPr>
@@ -862,7 +862,7 @@
           <p:cNvPr id="4" name="Date Placeholder 3">
             <a:extLst>
               <a:ext uri="{FF2B5EF4-FFF2-40B4-BE49-F238E27FC236}">
-                <a16:creationId xmlns:a16="http://schemas.microsoft.com/office/drawing/2014/main" id="{644E81FD-28F3-3957-CD90-6DD75D83FB0A}"/>
+                <a16:creationId xmlns:a16="http://schemas.microsoft.com/office/drawing/2014/main" id="{17D1525C-D0E5-4006-A9CB-4DF02985FC04}"/>
               </a:ext>
             </a:extLst>
           </p:cNvPr>
@@ -878,7 +878,7 @@
           <a:bodyPr/>
           <a:lstStyle/>
           <a:p>
-            <a:fld id="{3EF7019B-3CBE-473F-A852-41B4E9884D2B}" type="datetimeFigureOut">
+            <a:fld id="{CF59C9E7-27AD-49B0-9749-76DA7CA1A074}" type="datetimeFigureOut">
               <a:rPr lang="en-IN" smtClean="0"/>
               <a:t>13-10-2026</a:t>
             </a:fld>
@@ -891,7 +891,7 @@
           <p:cNvPr id="5" name="Footer Placeholder 4">
             <a:extLst>
               <a:ext uri="{FF2B5EF4-FFF2-40B4-BE49-F238E27FC236}">
-                <a16:creationId xmlns:a16="http://schemas.microsoft.com/office/drawing/2014/main" id="{D39F7BC4-80D9-D184-0C1E-7B034FC32F14}"/>
+                <a16:creationId xmlns:a16="http://schemas.microsoft.com/office/drawing/2014/main" id="{858C7BF5-AF54-BC64-6C2C-68C6947FD7CE}"/>
               </a:ext>
             </a:extLst>
           </p:cNvPr>
@@ -916,7 +916,7 @@
           <p:cNvPr id="6" name="Slide Number Placeholder 5">
             <a:extLst>
               <a:ext uri="{FF2B5EF4-FFF2-40B4-BE49-F238E27FC236}">
-                <a16:creationId xmlns:a16="http://schemas.microsoft.com/office/drawing/2014/main" id="{D0BBA639-E267-0721-83A9-9EDD378BEF17}"/>
+                <a16:creationId xmlns:a16="http://schemas.microsoft.com/office/drawing/2014/main" id="{F7AFA3CA-F522-8068-61FC-2A1F9C4B0FE9}"/>
               </a:ext>
             </a:extLst>
           </p:cNvPr>
@@ -932,7 +932,7 @@
           <a:bodyPr/>
           <a:lstStyle/>
           <a:p>
-            <a:fld id="{6E7CDEDE-B9A9-4A26-AEA8-F99C5C25440B}" type="slidenum">
+            <a:fld id="{A9C1A5ED-373C-43E3-A30A-7C89C8477F1A}" type="slidenum">
               <a:rPr lang="en-IN" smtClean="0"/>
               <a:t>‹#›</a:t>
             </a:fld>
@@ -943,7 +943,7 @@
     </p:spTree>
     <p:extLst>
       <p:ext uri="{BB962C8B-B14F-4D97-AF65-F5344CB8AC3E}">
-        <p14:creationId xmlns:p14="http://schemas.microsoft.com/office/powerpoint/2010/main" val="297655034"/>
+        <p14:creationId xmlns:p14="http://schemas.microsoft.com/office/powerpoint/2010/main" val="2697749081"/>
       </p:ext>
     </p:extLst>
   </p:cSld>
@@ -975,7 +975,7 @@
           <p:cNvPr id="2" name="Title 1">
             <a:extLst>
               <a:ext uri="{FF2B5EF4-FFF2-40B4-BE49-F238E27FC236}">
-                <a16:creationId xmlns:a16="http://schemas.microsoft.com/office/drawing/2014/main" id="{28FD7FD1-0F93-9441-184C-56C60BCD70F3}"/>
+                <a16:creationId xmlns:a16="http://schemas.microsoft.com/office/drawing/2014/main" id="{94EBAA92-83A1-7AB4-A4AE-4987CCFC78D6}"/>
               </a:ext>
             </a:extLst>
           </p:cNvPr>
@@ -1013,7 +1013,7 @@
           <p:cNvPr id="3" name="Text Placeholder 2">
             <a:extLst>
               <a:ext uri="{FF2B5EF4-FFF2-40B4-BE49-F238E27FC236}">
-                <a16:creationId xmlns:a16="http://schemas.microsoft.com/office/drawing/2014/main" id="{03E0EC37-334C-C485-A3DA-9D9A1C2B281A}"/>
+                <a16:creationId xmlns:a16="http://schemas.microsoft.com/office/drawing/2014/main" id="{B53587EC-7181-50BC-FC09-591F5DDBE279}"/>
               </a:ext>
             </a:extLst>
           </p:cNvPr>
@@ -1138,7 +1138,7 @@
           <p:cNvPr id="4" name="Date Placeholder 3">
             <a:extLst>
               <a:ext uri="{FF2B5EF4-FFF2-40B4-BE49-F238E27FC236}">
-                <a16:creationId xmlns:a16="http://schemas.microsoft.com/office/drawing/2014/main" id="{DED2B760-7375-4F0F-963A-61E4CF0D5B2E}"/>
+                <a16:creationId xmlns:a16="http://schemas.microsoft.com/office/drawing/2014/main" id="{772343D1-B1DF-E38D-9109-D29A855E044C}"/>
               </a:ext>
             </a:extLst>
           </p:cNvPr>
@@ -1154,7 +1154,7 @@
           <a:bodyPr/>
           <a:lstStyle/>
           <a:p>
-            <a:fld id="{3EF7019B-3CBE-473F-A852-41B4E9884D2B}" type="datetimeFigureOut">
+            <a:fld id="{CF59C9E7-27AD-49B0-9749-76DA7CA1A074}" type="datetimeFigureOut">
               <a:rPr lang="en-IN" smtClean="0"/>
               <a:t>13-10-2026</a:t>
             </a:fld>
@@ -1167,7 +1167,7 @@
           <p:cNvPr id="5" name="Footer Placeholder 4">
             <a:extLst>
               <a:ext uri="{FF2B5EF4-FFF2-40B4-BE49-F238E27FC236}">
-                <a16:creationId xmlns:a16="http://schemas.microsoft.com/office/drawing/2014/main" id="{EAC516CD-7829-B9B7-8560-100F1095AFAD}"/>
+                <a16:creationId xmlns:a16="http://schemas.microsoft.com/office/drawing/2014/main" id="{7B1601F5-AE98-B2D8-2C74-FFF31A4FD103}"/>
               </a:ext>
             </a:extLst>
           </p:cNvPr>
@@ -1192,7 +1192,7 @@
           <p:cNvPr id="6" name="Slide Number Placeholder 5">
             <a:extLst>
               <a:ext uri="{FF2B5EF4-FFF2-40B4-BE49-F238E27FC236}">
-                <a16:creationId xmlns:a16="http://schemas.microsoft.com/office/drawing/2014/main" id="{A543B78C-0AF9-A4A3-6226-36D88807EBF2}"/>
+                <a16:creationId xmlns:a16="http://schemas.microsoft.com/office/drawing/2014/main" id="{9754E9A4-186B-1038-7430-721D79E4CDD7}"/>
               </a:ext>
             </a:extLst>
           </p:cNvPr>
@@ -1208,7 +1208,7 @@
           <a:bodyPr/>
           <a:lstStyle/>
           <a:p>
-            <a:fld id="{6E7CDEDE-B9A9-4A26-AEA8-F99C5C25440B}" type="slidenum">
+            <a:fld id="{A9C1A5ED-373C-43E3-A30A-7C89C8477F1A}" type="slidenum">
               <a:rPr lang="en-IN" smtClean="0"/>
               <a:t>‹#›</a:t>
             </a:fld>
@@ -1219,7 +1219,7 @@
     </p:spTree>
     <p:extLst>
       <p:ext uri="{BB962C8B-B14F-4D97-AF65-F5344CB8AC3E}">
-        <p14:creationId xmlns:p14="http://schemas.microsoft.com/office/powerpoint/2010/main" val="643404767"/>
+        <p14:creationId xmlns:p14="http://schemas.microsoft.com/office/powerpoint/2010/main" val="4237274436"/>
       </p:ext>
     </p:extLst>
   </p:cSld>
@@ -1251,7 +1251,7 @@
           <p:cNvPr id="2" name="Title 1">
             <a:extLst>
               <a:ext uri="{FF2B5EF4-FFF2-40B4-BE49-F238E27FC236}">
-                <a16:creationId xmlns:a16="http://schemas.microsoft.com/office/drawing/2014/main" id="{46291676-95DC-A21C-5DB0-CB269E69D1E5}"/>
+                <a16:creationId xmlns:a16="http://schemas.microsoft.com/office/drawing/2014/main" id="{077B3BB6-6305-05AD-102D-2ED039888253}"/>
               </a:ext>
             </a:extLst>
           </p:cNvPr>
@@ -1280,7 +1280,7 @@
           <p:cNvPr id="3" name="Content Placeholder 2">
             <a:extLst>
               <a:ext uri="{FF2B5EF4-FFF2-40B4-BE49-F238E27FC236}">
-                <a16:creationId xmlns:a16="http://schemas.microsoft.com/office/drawing/2014/main" id="{1FEA7B38-355B-0EF5-0292-D2E624BBA627}"/>
+                <a16:creationId xmlns:a16="http://schemas.microsoft.com/office/drawing/2014/main" id="{1D365793-57D5-7B93-40DA-C3414D3904BC}"/>
               </a:ext>
             </a:extLst>
           </p:cNvPr>
@@ -1343,7 +1343,7 @@
           <p:cNvPr id="4" name="Content Placeholder 3">
             <a:extLst>
               <a:ext uri="{FF2B5EF4-FFF2-40B4-BE49-F238E27FC236}">
-                <a16:creationId xmlns:a16="http://schemas.microsoft.com/office/drawing/2014/main" id="{A54CA1C2-2B57-1A10-64CF-6C1C02AE1784}"/>
+                <a16:creationId xmlns:a16="http://schemas.microsoft.com/office/drawing/2014/main" id="{2E5475DC-C49F-462E-DFBB-0E3172999F14}"/>
               </a:ext>
             </a:extLst>
           </p:cNvPr>
@@ -1406,7 +1406,7 @@
           <p:cNvPr id="5" name="Date Placeholder 4">
             <a:extLst>
               <a:ext uri="{FF2B5EF4-FFF2-40B4-BE49-F238E27FC236}">
-                <a16:creationId xmlns:a16="http://schemas.microsoft.com/office/drawing/2014/main" id="{03D45EA9-A406-E089-A281-088FC3849F60}"/>
+                <a16:creationId xmlns:a16="http://schemas.microsoft.com/office/drawing/2014/main" id="{4F047FE0-3599-5AF5-0FFD-A61F06849645}"/>
               </a:ext>
             </a:extLst>
           </p:cNvPr>
@@ -1422,7 +1422,7 @@
           <a:bodyPr/>
           <a:lstStyle/>
           <a:p>
-            <a:fld id="{3EF7019B-3CBE-473F-A852-41B4E9884D2B}" type="datetimeFigureOut">
+            <a:fld id="{CF59C9E7-27AD-49B0-9749-76DA7CA1A074}" type="datetimeFigureOut">
               <a:rPr lang="en-IN" smtClean="0"/>
               <a:t>13-10-2026</a:t>
             </a:fld>
@@ -1435,7 +1435,7 @@
           <p:cNvPr id="6" name="Footer Placeholder 5">
             <a:extLst>
               <a:ext uri="{FF2B5EF4-FFF2-40B4-BE49-F238E27FC236}">
-                <a16:creationId xmlns:a16="http://schemas.microsoft.com/office/drawing/2014/main" id="{9E1FDBF0-1AC0-02EF-64C2-EEAB08273FFE}"/>
+                <a16:creationId xmlns:a16="http://schemas.microsoft.com/office/drawing/2014/main" id="{B4B7CE20-BEFF-9C78-D3C6-F3218B582C4C}"/>
               </a:ext>
             </a:extLst>
           </p:cNvPr>
@@ -1460,7 +1460,7 @@
           <p:cNvPr id="7" name="Slide Number Placeholder 6">
             <a:extLst>
               <a:ext uri="{FF2B5EF4-FFF2-40B4-BE49-F238E27FC236}">
-                <a16:creationId xmlns:a16="http://schemas.microsoft.com/office/drawing/2014/main" id="{17426A31-ADA6-ED1D-92D3-651B86DC6B3A}"/>
+                <a16:creationId xmlns:a16="http://schemas.microsoft.com/office/drawing/2014/main" id="{B248ACC9-D399-004B-12CC-2DBF13A9DBF2}"/>
               </a:ext>
             </a:extLst>
           </p:cNvPr>
@@ -1476,7 +1476,7 @@
           <a:bodyPr/>
           <a:lstStyle/>
           <a:p>
-            <a:fld id="{6E7CDEDE-B9A9-4A26-AEA8-F99C5C25440B}" type="slidenum">
+            <a:fld id="{A9C1A5ED-373C-43E3-A30A-7C89C8477F1A}" type="slidenum">
               <a:rPr lang="en-IN" smtClean="0"/>
               <a:t>‹#›</a:t>
             </a:fld>
@@ -1487,7 +1487,7 @@
     </p:spTree>
     <p:extLst>
       <p:ext uri="{BB962C8B-B14F-4D97-AF65-F5344CB8AC3E}">
-        <p14:creationId xmlns:p14="http://schemas.microsoft.com/office/powerpoint/2010/main" val="1294705994"/>
+        <p14:creationId xmlns:p14="http://schemas.microsoft.com/office/powerpoint/2010/main" val="612671765"/>
       </p:ext>
     </p:extLst>
   </p:cSld>
@@ -1519,7 +1519,7 @@
           <p:cNvPr id="2" name="Title 1">
             <a:extLst>
               <a:ext uri="{FF2B5EF4-FFF2-40B4-BE49-F238E27FC236}">
-                <a16:creationId xmlns:a16="http://schemas.microsoft.com/office/drawing/2014/main" id="{E007E743-0806-D8D3-1D35-CE844A67E3D8}"/>
+                <a16:creationId xmlns:a16="http://schemas.microsoft.com/office/drawing/2014/main" id="{CDC67422-341B-B46B-26B1-CB5FC645BA7B}"/>
               </a:ext>
             </a:extLst>
           </p:cNvPr>
@@ -1553,7 +1553,7 @@
           <p:cNvPr id="3" name="Text Placeholder 2">
             <a:extLst>
               <a:ext uri="{FF2B5EF4-FFF2-40B4-BE49-F238E27FC236}">
-                <a16:creationId xmlns:a16="http://schemas.microsoft.com/office/drawing/2014/main" id="{822A4256-4031-9A8B-F043-E44C63F1C02B}"/>
+                <a16:creationId xmlns:a16="http://schemas.microsoft.com/office/drawing/2014/main" id="{44F34272-8B1A-2189-B970-B57D51A47FFE}"/>
               </a:ext>
             </a:extLst>
           </p:cNvPr>
@@ -1624,7 +1624,7 @@
           <p:cNvPr id="4" name="Content Placeholder 3">
             <a:extLst>
               <a:ext uri="{FF2B5EF4-FFF2-40B4-BE49-F238E27FC236}">
-                <a16:creationId xmlns:a16="http://schemas.microsoft.com/office/drawing/2014/main" id="{8FCA0385-1049-2B86-2F6B-352D06CC4017}"/>
+                <a16:creationId xmlns:a16="http://schemas.microsoft.com/office/drawing/2014/main" id="{EB4E0E3B-D0DD-F5D1-9B5A-F875772828DA}"/>
               </a:ext>
             </a:extLst>
           </p:cNvPr>
@@ -1687,7 +1687,7 @@
           <p:cNvPr id="5" name="Text Placeholder 4">
             <a:extLst>
               <a:ext uri="{FF2B5EF4-FFF2-40B4-BE49-F238E27FC236}">
-                <a16:creationId xmlns:a16="http://schemas.microsoft.com/office/drawing/2014/main" id="{F12DDCF8-DCA8-E471-4FA4-074971A07228}"/>
+                <a16:creationId xmlns:a16="http://schemas.microsoft.com/office/drawing/2014/main" id="{64836857-8505-91F2-D949-32C3EA967BAA}"/>
               </a:ext>
             </a:extLst>
           </p:cNvPr>
@@ -1758,7 +1758,7 @@
           <p:cNvPr id="6" name="Content Placeholder 5">
             <a:extLst>
               <a:ext uri="{FF2B5EF4-FFF2-40B4-BE49-F238E27FC236}">
-                <a16:creationId xmlns:a16="http://schemas.microsoft.com/office/drawing/2014/main" id="{0C8D2396-5036-A4D2-C943-F76FF853498A}"/>
+                <a16:creationId xmlns:a16="http://schemas.microsoft.com/office/drawing/2014/main" id="{E8E92D95-B5F5-5325-0386-C77ED28367AC}"/>
               </a:ext>
             </a:extLst>
           </p:cNvPr>
@@ -1821,7 +1821,7 @@
           <p:cNvPr id="7" name="Date Placeholder 6">
             <a:extLst>
               <a:ext uri="{FF2B5EF4-FFF2-40B4-BE49-F238E27FC236}">
-                <a16:creationId xmlns:a16="http://schemas.microsoft.com/office/drawing/2014/main" id="{3E87FC37-FE25-AF53-524D-D1D82AF60EF5}"/>
+                <a16:creationId xmlns:a16="http://schemas.microsoft.com/office/drawing/2014/main" id="{CC5DEE00-E41F-906F-ABD3-5169805CA291}"/>
               </a:ext>
             </a:extLst>
           </p:cNvPr>
@@ -1837,7 +1837,7 @@
           <a:bodyPr/>
           <a:lstStyle/>
           <a:p>
-            <a:fld id="{3EF7019B-3CBE-473F-A852-41B4E9884D2B}" type="datetimeFigureOut">
+            <a:fld id="{CF59C9E7-27AD-49B0-9749-76DA7CA1A074}" type="datetimeFigureOut">
               <a:rPr lang="en-IN" smtClean="0"/>
               <a:t>13-10-2026</a:t>
             </a:fld>
@@ -1850,7 +1850,7 @@
           <p:cNvPr id="8" name="Footer Placeholder 7">
             <a:extLst>
               <a:ext uri="{FF2B5EF4-FFF2-40B4-BE49-F238E27FC236}">
-                <a16:creationId xmlns:a16="http://schemas.microsoft.com/office/drawing/2014/main" id="{BDA97369-78F3-8FF0-9A0D-356A27F97032}"/>
+                <a16:creationId xmlns:a16="http://schemas.microsoft.com/office/drawing/2014/main" id="{243CDC61-7C4C-1DD9-B56D-97FC2142C6C0}"/>
               </a:ext>
             </a:extLst>
           </p:cNvPr>
@@ -1875,7 +1875,7 @@
           <p:cNvPr id="9" name="Slide Number Placeholder 8">
             <a:extLst>
               <a:ext uri="{FF2B5EF4-FFF2-40B4-BE49-F238E27FC236}">
-                <a16:creationId xmlns:a16="http://schemas.microsoft.com/office/drawing/2014/main" id="{61DB418F-7FC5-D4E0-F470-E66A483BB3B7}"/>
+                <a16:creationId xmlns:a16="http://schemas.microsoft.com/office/drawing/2014/main" id="{AEB69373-DDAE-6C5A-CD92-E64B7F51068C}"/>
               </a:ext>
             </a:extLst>
           </p:cNvPr>
@@ -1891,7 +1891,7 @@
           <a:bodyPr/>
           <a:lstStyle/>
           <a:p>
-            <a:fld id="{6E7CDEDE-B9A9-4A26-AEA8-F99C5C25440B}" type="slidenum">
+            <a:fld id="{A9C1A5ED-373C-43E3-A30A-7C89C8477F1A}" type="slidenum">
               <a:rPr lang="en-IN" smtClean="0"/>
               <a:t>‹#›</a:t>
             </a:fld>
@@ -1902,7 +1902,7 @@
     </p:spTree>
     <p:extLst>
       <p:ext uri="{BB962C8B-B14F-4D97-AF65-F5344CB8AC3E}">
-        <p14:creationId xmlns:p14="http://schemas.microsoft.com/office/powerpoint/2010/main" val="2393974996"/>
+        <p14:creationId xmlns:p14="http://schemas.microsoft.com/office/powerpoint/2010/main" val="1688617448"/>
       </p:ext>
     </p:extLst>
   </p:cSld>
@@ -1934,7 +1934,7 @@
           <p:cNvPr id="2" name="Title 1">
             <a:extLst>
               <a:ext uri="{FF2B5EF4-FFF2-40B4-BE49-F238E27FC236}">
-                <a16:creationId xmlns:a16="http://schemas.microsoft.com/office/drawing/2014/main" id="{6CEAD109-1982-D316-BD5E-A28DB7DE82CE}"/>
+                <a16:creationId xmlns:a16="http://schemas.microsoft.com/office/drawing/2014/main" id="{F97065EE-BEF5-3443-0688-F633038402A5}"/>
               </a:ext>
             </a:extLst>
           </p:cNvPr>
@@ -1963,7 +1963,7 @@
           <p:cNvPr id="3" name="Date Placeholder 2">
             <a:extLst>
               <a:ext uri="{FF2B5EF4-FFF2-40B4-BE49-F238E27FC236}">
-                <a16:creationId xmlns:a16="http://schemas.microsoft.com/office/drawing/2014/main" id="{C90B6DD4-2C06-D449-D279-3DAEC7D6AF92}"/>
+                <a16:creationId xmlns:a16="http://schemas.microsoft.com/office/drawing/2014/main" id="{51313CB8-4BC1-8DEA-5E93-6B1004F72F4D}"/>
               </a:ext>
             </a:extLst>
           </p:cNvPr>
@@ -1979,7 +1979,7 @@
           <a:bodyPr/>
           <a:lstStyle/>
           <a:p>
-            <a:fld id="{3EF7019B-3CBE-473F-A852-41B4E9884D2B}" type="datetimeFigureOut">
+            <a:fld id="{CF59C9E7-27AD-49B0-9749-76DA7CA1A074}" type="datetimeFigureOut">
               <a:rPr lang="en-IN" smtClean="0"/>
               <a:t>13-10-2026</a:t>
             </a:fld>
@@ -1992,7 +1992,7 @@
           <p:cNvPr id="4" name="Footer Placeholder 3">
             <a:extLst>
               <a:ext uri="{FF2B5EF4-FFF2-40B4-BE49-F238E27FC236}">
-                <a16:creationId xmlns:a16="http://schemas.microsoft.com/office/drawing/2014/main" id="{0FCC2B3C-75B0-6FF6-ADA0-D716FAABDDC0}"/>
+                <a16:creationId xmlns:a16="http://schemas.microsoft.com/office/drawing/2014/main" id="{8EEBD674-A53A-D64B-40F7-2724B4D0EB7E}"/>
               </a:ext>
             </a:extLst>
           </p:cNvPr>
@@ -2017,7 +2017,7 @@
           <p:cNvPr id="5" name="Slide Number Placeholder 4">
             <a:extLst>
               <a:ext uri="{FF2B5EF4-FFF2-40B4-BE49-F238E27FC236}">
-                <a16:creationId xmlns:a16="http://schemas.microsoft.com/office/drawing/2014/main" id="{7A03D7A2-F08E-9BBE-0355-EC99BD80D4C4}"/>
+                <a16:creationId xmlns:a16="http://schemas.microsoft.com/office/drawing/2014/main" id="{F994D156-61E2-1458-5164-D4E27612D91B}"/>
               </a:ext>
             </a:extLst>
           </p:cNvPr>
@@ -2033,7 +2033,7 @@
           <a:bodyPr/>
           <a:lstStyle/>
           <a:p>
-            <a:fld id="{6E7CDEDE-B9A9-4A26-AEA8-F99C5C25440B}" type="slidenum">
+            <a:fld id="{A9C1A5ED-373C-43E3-A30A-7C89C8477F1A}" type="slidenum">
               <a:rPr lang="en-IN" smtClean="0"/>
               <a:t>‹#›</a:t>
             </a:fld>
@@ -2044,7 +2044,7 @@
     </p:spTree>
     <p:extLst>
       <p:ext uri="{BB962C8B-B14F-4D97-AF65-F5344CB8AC3E}">
-        <p14:creationId xmlns:p14="http://schemas.microsoft.com/office/powerpoint/2010/main" val="1732055765"/>
+        <p14:creationId xmlns:p14="http://schemas.microsoft.com/office/powerpoint/2010/main" val="1865518376"/>
       </p:ext>
     </p:extLst>
   </p:cSld>
@@ -2076,7 +2076,7 @@
           <p:cNvPr id="2" name="Date Placeholder 1">
             <a:extLst>
               <a:ext uri="{FF2B5EF4-FFF2-40B4-BE49-F238E27FC236}">
-                <a16:creationId xmlns:a16="http://schemas.microsoft.com/office/drawing/2014/main" id="{C0CEE399-60A7-59AF-48B4-11BB4444671B}"/>
+                <a16:creationId xmlns:a16="http://schemas.microsoft.com/office/drawing/2014/main" id="{C3B99D90-920C-782B-AA6E-14A145A59759}"/>
               </a:ext>
             </a:extLst>
           </p:cNvPr>
@@ -2092,7 +2092,7 @@
           <a:bodyPr/>
           <a:lstStyle/>
           <a:p>
-            <a:fld id="{3EF7019B-3CBE-473F-A852-41B4E9884D2B}" type="datetimeFigureOut">
+            <a:fld id="{CF59C9E7-27AD-49B0-9749-76DA7CA1A074}" type="datetimeFigureOut">
               <a:rPr lang="en-IN" smtClean="0"/>
               <a:t>13-10-2026</a:t>
             </a:fld>
@@ -2105,7 +2105,7 @@
           <p:cNvPr id="3" name="Footer Placeholder 2">
             <a:extLst>
               <a:ext uri="{FF2B5EF4-FFF2-40B4-BE49-F238E27FC236}">
-                <a16:creationId xmlns:a16="http://schemas.microsoft.com/office/drawing/2014/main" id="{E3245951-9793-504A-6AAA-18843D4BBFFA}"/>
+                <a16:creationId xmlns:a16="http://schemas.microsoft.com/office/drawing/2014/main" id="{3B182693-24D4-834B-28D2-6B75BDCECCE7}"/>
               </a:ext>
             </a:extLst>
           </p:cNvPr>
@@ -2130,7 +2130,7 @@
           <p:cNvPr id="4" name="Slide Number Placeholder 3">
             <a:extLst>
               <a:ext uri="{FF2B5EF4-FFF2-40B4-BE49-F238E27FC236}">
-                <a16:creationId xmlns:a16="http://schemas.microsoft.com/office/drawing/2014/main" id="{165A5844-49AB-8957-C102-6D785225FBD5}"/>
+                <a16:creationId xmlns:a16="http://schemas.microsoft.com/office/drawing/2014/main" id="{9B59486B-B460-7CAD-B104-EB60B6688841}"/>
               </a:ext>
             </a:extLst>
           </p:cNvPr>
@@ -2146,7 +2146,7 @@
           <a:bodyPr/>
           <a:lstStyle/>
           <a:p>
-            <a:fld id="{6E7CDEDE-B9A9-4A26-AEA8-F99C5C25440B}" type="slidenum">
+            <a:fld id="{A9C1A5ED-373C-43E3-A30A-7C89C8477F1A}" type="slidenum">
               <a:rPr lang="en-IN" smtClean="0"/>
               <a:t>‹#›</a:t>
             </a:fld>
@@ -2157,7 +2157,7 @@
     </p:spTree>
     <p:extLst>
       <p:ext uri="{BB962C8B-B14F-4D97-AF65-F5344CB8AC3E}">
-        <p14:creationId xmlns:p14="http://schemas.microsoft.com/office/powerpoint/2010/main" val="780628245"/>
+        <p14:creationId xmlns:p14="http://schemas.microsoft.com/office/powerpoint/2010/main" val="3907887458"/>
       </p:ext>
     </p:extLst>
   </p:cSld>
@@ -2189,7 +2189,7 @@
           <p:cNvPr id="2" name="Title 1">
             <a:extLst>
               <a:ext uri="{FF2B5EF4-FFF2-40B4-BE49-F238E27FC236}">
-                <a16:creationId xmlns:a16="http://schemas.microsoft.com/office/drawing/2014/main" id="{7CCFF2D4-2F24-101C-8060-FB9A923BA8A0}"/>
+                <a16:creationId xmlns:a16="http://schemas.microsoft.com/office/drawing/2014/main" id="{F7E82166-94A6-41C2-F460-396D0F6302BB}"/>
               </a:ext>
             </a:extLst>
           </p:cNvPr>
@@ -2227,7 +2227,7 @@
           <p:cNvPr id="3" name="Content Placeholder 2">
             <a:extLst>
               <a:ext uri="{FF2B5EF4-FFF2-40B4-BE49-F238E27FC236}">
-                <a16:creationId xmlns:a16="http://schemas.microsoft.com/office/drawing/2014/main" id="{7F206850-4AD6-F349-C7EE-E9FE21D37092}"/>
+                <a16:creationId xmlns:a16="http://schemas.microsoft.com/office/drawing/2014/main" id="{36E1D64B-6EDE-FD19-32B0-32C587D445FC}"/>
               </a:ext>
             </a:extLst>
           </p:cNvPr>
@@ -2318,7 +2318,7 @@
           <p:cNvPr id="4" name="Text Placeholder 3">
             <a:extLst>
               <a:ext uri="{FF2B5EF4-FFF2-40B4-BE49-F238E27FC236}">
-                <a16:creationId xmlns:a16="http://schemas.microsoft.com/office/drawing/2014/main" id="{6FD60375-A309-5EFF-BD77-9C59E5760304}"/>
+                <a16:creationId xmlns:a16="http://schemas.microsoft.com/office/drawing/2014/main" id="{0EC80366-E538-6CD3-0C8E-B85A6AC60C4F}"/>
               </a:ext>
             </a:extLst>
           </p:cNvPr>
@@ -2389,7 +2389,7 @@
           <p:cNvPr id="5" name="Date Placeholder 4">
             <a:extLst>
               <a:ext uri="{FF2B5EF4-FFF2-40B4-BE49-F238E27FC236}">
-                <a16:creationId xmlns:a16="http://schemas.microsoft.com/office/drawing/2014/main" id="{9D14EAB7-3C9D-5F55-37A1-A406A022CFDB}"/>
+                <a16:creationId xmlns:a16="http://schemas.microsoft.com/office/drawing/2014/main" id="{81B375F2-7B76-176B-C19A-BE188A8C3C78}"/>
               </a:ext>
             </a:extLst>
           </p:cNvPr>
@@ -2405,7 +2405,7 @@
           <a:bodyPr/>
           <a:lstStyle/>
           <a:p>
-            <a:fld id="{3EF7019B-3CBE-473F-A852-41B4E9884D2B}" type="datetimeFigureOut">
+            <a:fld id="{CF59C9E7-27AD-49B0-9749-76DA7CA1A074}" type="datetimeFigureOut">
               <a:rPr lang="en-IN" smtClean="0"/>
               <a:t>13-10-2026</a:t>
             </a:fld>
@@ -2418,7 +2418,7 @@
           <p:cNvPr id="6" name="Footer Placeholder 5">
             <a:extLst>
               <a:ext uri="{FF2B5EF4-FFF2-40B4-BE49-F238E27FC236}">
-                <a16:creationId xmlns:a16="http://schemas.microsoft.com/office/drawing/2014/main" id="{C2B8CB81-4055-E2D3-3B61-4F8BFE517F3A}"/>
+                <a16:creationId xmlns:a16="http://schemas.microsoft.com/office/drawing/2014/main" id="{6B01658F-ABE4-C35B-E10C-EE149FEC8E8F}"/>
               </a:ext>
             </a:extLst>
           </p:cNvPr>
@@ -2443,7 +2443,7 @@
           <p:cNvPr id="7" name="Slide Number Placeholder 6">
             <a:extLst>
               <a:ext uri="{FF2B5EF4-FFF2-40B4-BE49-F238E27FC236}">
-                <a16:creationId xmlns:a16="http://schemas.microsoft.com/office/drawing/2014/main" id="{A53134B9-7477-7AA3-9221-84A38DDA67C7}"/>
+                <a16:creationId xmlns:a16="http://schemas.microsoft.com/office/drawing/2014/main" id="{B144E4FC-D0BF-FB03-42A6-E638F297C141}"/>
               </a:ext>
             </a:extLst>
           </p:cNvPr>
@@ -2459,7 +2459,7 @@
           <a:bodyPr/>
           <a:lstStyle/>
           <a:p>
-            <a:fld id="{6E7CDEDE-B9A9-4A26-AEA8-F99C5C25440B}" type="slidenum">
+            <a:fld id="{A9C1A5ED-373C-43E3-A30A-7C89C8477F1A}" type="slidenum">
               <a:rPr lang="en-IN" smtClean="0"/>
               <a:t>‹#›</a:t>
             </a:fld>
@@ -2470,7 +2470,7 @@
     </p:spTree>
     <p:extLst>
       <p:ext uri="{BB962C8B-B14F-4D97-AF65-F5344CB8AC3E}">
-        <p14:creationId xmlns:p14="http://schemas.microsoft.com/office/powerpoint/2010/main" val="1865860615"/>
+        <p14:creationId xmlns:p14="http://schemas.microsoft.com/office/powerpoint/2010/main" val="203207269"/>
       </p:ext>
     </p:extLst>
   </p:cSld>
@@ -2502,7 +2502,7 @@
           <p:cNvPr id="2" name="Title 1">
             <a:extLst>
               <a:ext uri="{FF2B5EF4-FFF2-40B4-BE49-F238E27FC236}">
-                <a16:creationId xmlns:a16="http://schemas.microsoft.com/office/drawing/2014/main" id="{25BD3627-0A9D-796F-58DE-B6F5EB66C000}"/>
+                <a16:creationId xmlns:a16="http://schemas.microsoft.com/office/drawing/2014/main" id="{9B94EE92-3C41-9123-DB76-BDFBD15296C3}"/>
               </a:ext>
             </a:extLst>
           </p:cNvPr>
@@ -2540,7 +2540,7 @@
           <p:cNvPr id="3" name="Picture Placeholder 2">
             <a:extLst>
               <a:ext uri="{FF2B5EF4-FFF2-40B4-BE49-F238E27FC236}">
-                <a16:creationId xmlns:a16="http://schemas.microsoft.com/office/drawing/2014/main" id="{BF083878-191E-2390-804E-D221E54A2E36}"/>
+                <a16:creationId xmlns:a16="http://schemas.microsoft.com/office/drawing/2014/main" id="{6A4ED1BE-CD7B-3A88-632E-23867E39561D}"/>
               </a:ext>
             </a:extLst>
           </p:cNvPr>
@@ -2607,7 +2607,7 @@
           <p:cNvPr id="4" name="Text Placeholder 3">
             <a:extLst>
               <a:ext uri="{FF2B5EF4-FFF2-40B4-BE49-F238E27FC236}">
-                <a16:creationId xmlns:a16="http://schemas.microsoft.com/office/drawing/2014/main" id="{254D3050-03C9-7845-935C-D9C346C9E584}"/>
+                <a16:creationId xmlns:a16="http://schemas.microsoft.com/office/drawing/2014/main" id="{D196F0D7-1EBA-DACE-5340-8A0F570353F6}"/>
               </a:ext>
             </a:extLst>
           </p:cNvPr>
@@ -2678,7 +2678,7 @@
           <p:cNvPr id="5" name="Date Placeholder 4">
             <a:extLst>
               <a:ext uri="{FF2B5EF4-FFF2-40B4-BE49-F238E27FC236}">
-                <a16:creationId xmlns:a16="http://schemas.microsoft.com/office/drawing/2014/main" id="{1410926B-AD03-7B90-3FD7-C136A05B2A48}"/>
+                <a16:creationId xmlns:a16="http://schemas.microsoft.com/office/drawing/2014/main" id="{496A45BA-8F0D-03B0-392C-59EA96F36D4D}"/>
               </a:ext>
             </a:extLst>
           </p:cNvPr>
@@ -2694,7 +2694,7 @@
           <a:bodyPr/>
           <a:lstStyle/>
           <a:p>
-            <a:fld id="{3EF7019B-3CBE-473F-A852-41B4E9884D2B}" type="datetimeFigureOut">
+            <a:fld id="{CF59C9E7-27AD-49B0-9749-76DA7CA1A074}" type="datetimeFigureOut">
               <a:rPr lang="en-IN" smtClean="0"/>
               <a:t>13-10-2026</a:t>
             </a:fld>
@@ -2707,7 +2707,7 @@
           <p:cNvPr id="6" name="Footer Placeholder 5">
             <a:extLst>
               <a:ext uri="{FF2B5EF4-FFF2-40B4-BE49-F238E27FC236}">
-                <a16:creationId xmlns:a16="http://schemas.microsoft.com/office/drawing/2014/main" id="{FB1CAE43-D1EF-A121-280C-39621BF28970}"/>
+                <a16:creationId xmlns:a16="http://schemas.microsoft.com/office/drawing/2014/main" id="{1A396ED8-6D6F-34B2-2239-92261DDBC503}"/>
               </a:ext>
             </a:extLst>
           </p:cNvPr>
@@ -2732,7 +2732,7 @@
           <p:cNvPr id="7" name="Slide Number Placeholder 6">
             <a:extLst>
               <a:ext uri="{FF2B5EF4-FFF2-40B4-BE49-F238E27FC236}">
-                <a16:creationId xmlns:a16="http://schemas.microsoft.com/office/drawing/2014/main" id="{EA27682A-B2D7-1201-BEAE-147BC0873198}"/>
+                <a16:creationId xmlns:a16="http://schemas.microsoft.com/office/drawing/2014/main" id="{282A6B34-9534-B8F4-F65A-52C5D21F1E76}"/>
               </a:ext>
             </a:extLst>
           </p:cNvPr>
@@ -2748,7 +2748,7 @@
           <a:bodyPr/>
           <a:lstStyle/>
           <a:p>
-            <a:fld id="{6E7CDEDE-B9A9-4A26-AEA8-F99C5C25440B}" type="slidenum">
+            <a:fld id="{A9C1A5ED-373C-43E3-A30A-7C89C8477F1A}" type="slidenum">
               <a:rPr lang="en-IN" smtClean="0"/>
               <a:t>‹#›</a:t>
             </a:fld>
@@ -2759,7 +2759,7 @@
     </p:spTree>
     <p:extLst>
       <p:ext uri="{BB962C8B-B14F-4D97-AF65-F5344CB8AC3E}">
-        <p14:creationId xmlns:p14="http://schemas.microsoft.com/office/powerpoint/2010/main" val="2431663093"/>
+        <p14:creationId xmlns:p14="http://schemas.microsoft.com/office/powerpoint/2010/main" val="3216020081"/>
       </p:ext>
     </p:extLst>
   </p:cSld>
@@ -2796,7 +2796,7 @@
           <p:cNvPr id="2" name="Title Placeholder 1">
             <a:extLst>
               <a:ext uri="{FF2B5EF4-FFF2-40B4-BE49-F238E27FC236}">
-                <a16:creationId xmlns:a16="http://schemas.microsoft.com/office/drawing/2014/main" id="{B6AC863A-E3E5-63CE-E001-2C9311F52623}"/>
+                <a16:creationId xmlns:a16="http://schemas.microsoft.com/office/drawing/2014/main" id="{43C55884-C06E-C45D-1AF1-5CA231006F02}"/>
               </a:ext>
             </a:extLst>
           </p:cNvPr>
@@ -2835,7 +2835,7 @@
           <p:cNvPr id="3" name="Text Placeholder 2">
             <a:extLst>
               <a:ext uri="{FF2B5EF4-FFF2-40B4-BE49-F238E27FC236}">
-                <a16:creationId xmlns:a16="http://schemas.microsoft.com/office/drawing/2014/main" id="{5FA3152E-95C5-BAE7-B0C7-F7C684354DF2}"/>
+                <a16:creationId xmlns:a16="http://schemas.microsoft.com/office/drawing/2014/main" id="{DA2E13AE-2D28-9B82-2BD3-1F2068E63E80}"/>
               </a:ext>
             </a:extLst>
           </p:cNvPr>
@@ -2903,7 +2903,7 @@
           <p:cNvPr id="4" name="Date Placeholder 3">
             <a:extLst>
               <a:ext uri="{FF2B5EF4-FFF2-40B4-BE49-F238E27FC236}">
-                <a16:creationId xmlns:a16="http://schemas.microsoft.com/office/drawing/2014/main" id="{623FEDF5-D7B6-AA3F-989C-A1DAF436DC8B}"/>
+                <a16:creationId xmlns:a16="http://schemas.microsoft.com/office/drawing/2014/main" id="{A60D2CCD-FBF4-FFC0-10E0-8402A15B2D50}"/>
               </a:ext>
             </a:extLst>
           </p:cNvPr>
@@ -2937,7 +2937,7 @@
             </a:lvl1pPr>
           </a:lstStyle>
           <a:p>
-            <a:fld id="{3EF7019B-3CBE-473F-A852-41B4E9884D2B}" type="datetimeFigureOut">
+            <a:fld id="{CF59C9E7-27AD-49B0-9749-76DA7CA1A074}" type="datetimeFigureOut">
               <a:rPr lang="en-IN" smtClean="0"/>
               <a:t>13-10-2026</a:t>
             </a:fld>
@@ -2950,7 +2950,7 @@
           <p:cNvPr id="5" name="Footer Placeholder 4">
             <a:extLst>
               <a:ext uri="{FF2B5EF4-FFF2-40B4-BE49-F238E27FC236}">
-                <a16:creationId xmlns:a16="http://schemas.microsoft.com/office/drawing/2014/main" id="{8117E570-B8FB-A3CC-9830-3845F1261129}"/>
+                <a16:creationId xmlns:a16="http://schemas.microsoft.com/office/drawing/2014/main" id="{A39D0097-6911-7D90-8190-2CAAD78AF934}"/>
               </a:ext>
             </a:extLst>
           </p:cNvPr>
@@ -2993,7 +2993,7 @@
           <p:cNvPr id="6" name="Slide Number Placeholder 5">
             <a:extLst>
               <a:ext uri="{FF2B5EF4-FFF2-40B4-BE49-F238E27FC236}">
-                <a16:creationId xmlns:a16="http://schemas.microsoft.com/office/drawing/2014/main" id="{6907DBD0-E867-41A1-ACA9-A5618C5B25FD}"/>
+                <a16:creationId xmlns:a16="http://schemas.microsoft.com/office/drawing/2014/main" id="{7C9D7514-164D-C3D1-5860-A73B1386EDC7}"/>
               </a:ext>
             </a:extLst>
           </p:cNvPr>
@@ -3027,7 +3027,7 @@
             </a:lvl1pPr>
           </a:lstStyle>
           <a:p>
-            <a:fld id="{6E7CDEDE-B9A9-4A26-AEA8-F99C5C25440B}" type="slidenum">
+            <a:fld id="{A9C1A5ED-373C-43E3-A30A-7C89C8477F1A}" type="slidenum">
               <a:rPr lang="en-IN" smtClean="0"/>
               <a:t>‹#›</a:t>
             </a:fld>
@@ -3038,7 +3038,7 @@
     </p:spTree>
     <p:extLst>
       <p:ext uri="{BB962C8B-B14F-4D97-AF65-F5344CB8AC3E}">
-        <p14:creationId xmlns:p14="http://schemas.microsoft.com/office/powerpoint/2010/main" val="140087194"/>
+        <p14:creationId xmlns:p14="http://schemas.microsoft.com/office/powerpoint/2010/main" val="4258261304"/>
       </p:ext>
     </p:extLst>
   </p:cSld>
@@ -3361,7 +3361,7 @@
           <p:cNvPr id="2" name="Rectangle 1">
             <a:extLst>
               <a:ext uri="{FF2B5EF4-FFF2-40B4-BE49-F238E27FC236}">
-                <a16:creationId xmlns:a16="http://schemas.microsoft.com/office/drawing/2014/main" id="{21DB7628-7F1D-3060-52C1-D8BFC8339418}"/>
+                <a16:creationId xmlns:a16="http://schemas.microsoft.com/office/drawing/2014/main" id="{AD8B75C8-C745-04C8-E4AD-1E4D96153547}"/>
               </a:ext>
             </a:extLst>
           </p:cNvPr>
@@ -3429,7 +3429,7 @@
           <p:cNvPr id="3" name="Rectangle 2">
             <a:extLst>
               <a:ext uri="{FF2B5EF4-FFF2-40B4-BE49-F238E27FC236}">
-                <a16:creationId xmlns:a16="http://schemas.microsoft.com/office/drawing/2014/main" id="{26E4EAD8-484A-3D64-975F-B53A73CCC032}"/>
+                <a16:creationId xmlns:a16="http://schemas.microsoft.com/office/drawing/2014/main" id="{210428D5-C526-E91F-C271-A794DB3AD787}"/>
               </a:ext>
             </a:extLst>
           </p:cNvPr>
@@ -3497,7 +3497,7 @@
           <p:cNvPr id="4" name="TextBox 3">
             <a:extLst>
               <a:ext uri="{FF2B5EF4-FFF2-40B4-BE49-F238E27FC236}">
-                <a16:creationId xmlns:a16="http://schemas.microsoft.com/office/drawing/2014/main" id="{C55FB9DA-3962-9DFA-E532-ACBBC06198B2}"/>
+                <a16:creationId xmlns:a16="http://schemas.microsoft.com/office/drawing/2014/main" id="{C0AFE680-6669-D55D-169D-361327DC6975}"/>
               </a:ext>
             </a:extLst>
           </p:cNvPr>
@@ -3543,7 +3543,7 @@
           <p:cNvPr id="5" name="TextBox 4">
             <a:extLst>
               <a:ext uri="{FF2B5EF4-FFF2-40B4-BE49-F238E27FC236}">
-                <a16:creationId xmlns:a16="http://schemas.microsoft.com/office/drawing/2014/main" id="{5284D136-246C-18E1-B6A7-40CD66013AAF}"/>
+                <a16:creationId xmlns:a16="http://schemas.microsoft.com/office/drawing/2014/main" id="{BE6191F0-4DA9-029B-21F8-3A6BB7D76FB2}"/>
               </a:ext>
             </a:extLst>
           </p:cNvPr>
@@ -3553,7 +3553,7 @@
         <p:spPr>
           <a:xfrm>
             <a:off x="508000" y="1016000"/>
-            <a:ext cx="11176000" cy="892552"/>
+            <a:ext cx="11176000" cy="1092607"/>
           </a:xfrm>
           <a:prstGeom prst="rect">
             <a:avLst/>
@@ -3576,7 +3576,8 @@
               <a:t>Java Project Based Learning (PBL) - 5th Semester | Dept. of CSE
 Arya College of Engineering and I.T., Jaipur
 Mentor: Er. Ram Babu Buri
-Team: Aryan Kumar Singh (Lead), Awantika Jaiswal, Devansh Maini, Aviral Joshi, Akshita Mawaliya</a:t>
+Team: Shaurya Dixit (Lead), Yashvardhan Singh Chauhan, Vaibhav Tank, Rajveer Singh Ranawat, Yashpal Singh Bhati
+Data Source: Kaggle Academic Research Paper Corpus</a:t>
             </a:r>
           </a:p>
         </p:txBody>
@@ -3586,7 +3587,7 @@
           <p:cNvPr id="6" name="TextBox 5">
             <a:extLst>
               <a:ext uri="{FF2B5EF4-FFF2-40B4-BE49-F238E27FC236}">
-                <a16:creationId xmlns:a16="http://schemas.microsoft.com/office/drawing/2014/main" id="{E3A7919E-6ED6-E510-54D3-D86F061DAF86}"/>
+                <a16:creationId xmlns:a16="http://schemas.microsoft.com/office/drawing/2014/main" id="{1C173F78-2371-9685-9054-CBDB1AA9F96D}"/>
               </a:ext>
             </a:extLst>
           </p:cNvPr>
@@ -3616,7 +3617,7 @@
                 </a:solidFill>
                 <a:latin typeface="Segoe UI" panose="020B0502040204020203" pitchFamily="34" charset="0"/>
               </a:rPr>
-              <a:t>Speaker: Aryan Kumar Singh (Team Leader)</a:t>
+              <a:t>Speaker: Shaurya Dixit (Team Leader)</a:t>
             </a:r>
             <a:endParaRPr lang="en-IN" sz="1200" b="1">
               <a:solidFill>
@@ -3632,7 +3633,7 @@
           <p:cNvPr id="7" name="TextBox 6">
             <a:extLst>
               <a:ext uri="{FF2B5EF4-FFF2-40B4-BE49-F238E27FC236}">
-                <a16:creationId xmlns:a16="http://schemas.microsoft.com/office/drawing/2014/main" id="{D686A982-B353-F2F4-C9B3-D9DD27419D58}"/>
+                <a16:creationId xmlns:a16="http://schemas.microsoft.com/office/drawing/2014/main" id="{F66ABBE8-A226-5612-6C61-C9C24D548EAB}"/>
               </a:ext>
             </a:extLst>
           </p:cNvPr>
@@ -3670,7 +3671,7 @@
     </p:spTree>
     <p:extLst>
       <p:ext uri="{BB962C8B-B14F-4D97-AF65-F5344CB8AC3E}">
-        <p14:creationId xmlns:p14="http://schemas.microsoft.com/office/powerpoint/2010/main" val="4095351233"/>
+        <p14:creationId xmlns:p14="http://schemas.microsoft.com/office/powerpoint/2010/main" val="858356429"/>
       </p:ext>
     </p:extLst>
   </p:cSld>
@@ -3702,7 +3703,7 @@
           <p:cNvPr id="2" name="Rectangle 1">
             <a:extLst>
               <a:ext uri="{FF2B5EF4-FFF2-40B4-BE49-F238E27FC236}">
-                <a16:creationId xmlns:a16="http://schemas.microsoft.com/office/drawing/2014/main" id="{EFFF7DF1-E160-60E8-A62C-3A2657A90325}"/>
+                <a16:creationId xmlns:a16="http://schemas.microsoft.com/office/drawing/2014/main" id="{11F94256-019D-7482-1938-533F3C6308AA}"/>
               </a:ext>
             </a:extLst>
           </p:cNvPr>
@@ -3770,7 +3771,7 @@
           <p:cNvPr id="3" name="Rectangle 2">
             <a:extLst>
               <a:ext uri="{FF2B5EF4-FFF2-40B4-BE49-F238E27FC236}">
-                <a16:creationId xmlns:a16="http://schemas.microsoft.com/office/drawing/2014/main" id="{815FE8EB-36A4-4171-2829-1C30CFB0A49F}"/>
+                <a16:creationId xmlns:a16="http://schemas.microsoft.com/office/drawing/2014/main" id="{CCB8F76B-9DD8-41AC-6F3D-4C2B9B2A5B48}"/>
               </a:ext>
             </a:extLst>
           </p:cNvPr>
@@ -3838,7 +3839,7 @@
           <p:cNvPr id="4" name="TextBox 3">
             <a:extLst>
               <a:ext uri="{FF2B5EF4-FFF2-40B4-BE49-F238E27FC236}">
-                <a16:creationId xmlns:a16="http://schemas.microsoft.com/office/drawing/2014/main" id="{DCA6975D-57C0-3FA6-D3D6-1E2037FD67B8}"/>
+                <a16:creationId xmlns:a16="http://schemas.microsoft.com/office/drawing/2014/main" id="{62170DEB-2528-3C33-8171-FF3FBE682EF5}"/>
               </a:ext>
             </a:extLst>
           </p:cNvPr>
@@ -3878,7 +3879,7 @@
           <p:cNvPr id="5" name="TextBox 4">
             <a:extLst>
               <a:ext uri="{FF2B5EF4-FFF2-40B4-BE49-F238E27FC236}">
-                <a16:creationId xmlns:a16="http://schemas.microsoft.com/office/drawing/2014/main" id="{B263AD44-91E5-D38C-A86E-A6A17A84C0F3}"/>
+                <a16:creationId xmlns:a16="http://schemas.microsoft.com/office/drawing/2014/main" id="{17D48CF0-4A85-E00D-1471-2118A2B05878}"/>
               </a:ext>
             </a:extLst>
           </p:cNvPr>
@@ -3918,7 +3919,7 @@
           <p:cNvPr id="6" name="TextBox 5">
             <a:extLst>
               <a:ext uri="{FF2B5EF4-FFF2-40B4-BE49-F238E27FC236}">
-                <a16:creationId xmlns:a16="http://schemas.microsoft.com/office/drawing/2014/main" id="{2CE44D6E-9F6D-5803-F717-B408355CFEE4}"/>
+                <a16:creationId xmlns:a16="http://schemas.microsoft.com/office/drawing/2014/main" id="{BE8B4E38-2D1B-1B5B-D8BD-FD6528642377}"/>
               </a:ext>
             </a:extLst>
           </p:cNvPr>
@@ -3948,7 +3949,7 @@
                 </a:solidFill>
                 <a:latin typeface="Segoe UI" panose="020B0502040204020203" pitchFamily="34" charset="0"/>
               </a:rPr>
-              <a:t>Speaker: Akshita Mawaliya</a:t>
+              <a:t>Speaker: Yashpal Singh Bhati</a:t>
             </a:r>
           </a:p>
         </p:txBody>
@@ -3958,7 +3959,7 @@
           <p:cNvPr id="7" name="TextBox 6">
             <a:extLst>
               <a:ext uri="{FF2B5EF4-FFF2-40B4-BE49-F238E27FC236}">
-                <a16:creationId xmlns:a16="http://schemas.microsoft.com/office/drawing/2014/main" id="{61253114-BAF6-2329-F7F4-31B2630798EA}"/>
+                <a16:creationId xmlns:a16="http://schemas.microsoft.com/office/drawing/2014/main" id="{8B4EF5AD-FD34-19D3-390A-74DF39C23A71}"/>
               </a:ext>
             </a:extLst>
           </p:cNvPr>
@@ -4002,7 +4003,7 @@
           <p:cNvPr id="8" name="TextBox 7">
             <a:extLst>
               <a:ext uri="{FF2B5EF4-FFF2-40B4-BE49-F238E27FC236}">
-                <a16:creationId xmlns:a16="http://schemas.microsoft.com/office/drawing/2014/main" id="{30544330-B36E-D237-C705-60A03444C009}"/>
+                <a16:creationId xmlns:a16="http://schemas.microsoft.com/office/drawing/2014/main" id="{0938730A-C8B6-7593-EE27-4BA57488FC47}"/>
               </a:ext>
             </a:extLst>
           </p:cNvPr>
@@ -4040,7 +4041,7 @@
     </p:spTree>
     <p:extLst>
       <p:ext uri="{BB962C8B-B14F-4D97-AF65-F5344CB8AC3E}">
-        <p14:creationId xmlns:p14="http://schemas.microsoft.com/office/powerpoint/2010/main" val="2751817054"/>
+        <p14:creationId xmlns:p14="http://schemas.microsoft.com/office/powerpoint/2010/main" val="3627151626"/>
       </p:ext>
     </p:extLst>
   </p:cSld>
@@ -4072,7 +4073,7 @@
           <p:cNvPr id="2" name="Rectangle 1">
             <a:extLst>
               <a:ext uri="{FF2B5EF4-FFF2-40B4-BE49-F238E27FC236}">
-                <a16:creationId xmlns:a16="http://schemas.microsoft.com/office/drawing/2014/main" id="{3515CFC2-97A0-540D-13E7-34845878868E}"/>
+                <a16:creationId xmlns:a16="http://schemas.microsoft.com/office/drawing/2014/main" id="{89009454-912B-6365-0998-F72124023633}"/>
               </a:ext>
             </a:extLst>
           </p:cNvPr>
@@ -4140,7 +4141,7 @@
           <p:cNvPr id="3" name="Rectangle 2">
             <a:extLst>
               <a:ext uri="{FF2B5EF4-FFF2-40B4-BE49-F238E27FC236}">
-                <a16:creationId xmlns:a16="http://schemas.microsoft.com/office/drawing/2014/main" id="{28E307FE-E543-5410-F731-45205B36EE37}"/>
+                <a16:creationId xmlns:a16="http://schemas.microsoft.com/office/drawing/2014/main" id="{92E7C43B-F95B-8CD9-7755-C2635203A28C}"/>
               </a:ext>
             </a:extLst>
           </p:cNvPr>
@@ -4208,7 +4209,7 @@
           <p:cNvPr id="4" name="TextBox 3">
             <a:extLst>
               <a:ext uri="{FF2B5EF4-FFF2-40B4-BE49-F238E27FC236}">
-                <a16:creationId xmlns:a16="http://schemas.microsoft.com/office/drawing/2014/main" id="{4263E441-CF91-DB65-ADEE-B5E650D0E63B}"/>
+                <a16:creationId xmlns:a16="http://schemas.microsoft.com/office/drawing/2014/main" id="{CEE2548D-9D12-CA4D-0A91-79D9F0F52A97}"/>
               </a:ext>
             </a:extLst>
           </p:cNvPr>
@@ -4248,7 +4249,7 @@
           <p:cNvPr id="5" name="TextBox 4">
             <a:extLst>
               <a:ext uri="{FF2B5EF4-FFF2-40B4-BE49-F238E27FC236}">
-                <a16:creationId xmlns:a16="http://schemas.microsoft.com/office/drawing/2014/main" id="{49A34CB7-C148-269B-4551-2F4F152C36F5}"/>
+                <a16:creationId xmlns:a16="http://schemas.microsoft.com/office/drawing/2014/main" id="{C5CDBD19-6E3D-B31C-4099-65BE4E1D8F49}"/>
               </a:ext>
             </a:extLst>
           </p:cNvPr>
@@ -4294,7 +4295,7 @@
           <p:cNvPr id="6" name="TextBox 5">
             <a:extLst>
               <a:ext uri="{FF2B5EF4-FFF2-40B4-BE49-F238E27FC236}">
-                <a16:creationId xmlns:a16="http://schemas.microsoft.com/office/drawing/2014/main" id="{5B3CD6E8-948A-8F20-0644-C738E530D400}"/>
+                <a16:creationId xmlns:a16="http://schemas.microsoft.com/office/drawing/2014/main" id="{29327C37-5EF2-3DC3-F91B-69B452E5540B}"/>
               </a:ext>
             </a:extLst>
           </p:cNvPr>
@@ -4324,7 +4325,7 @@
                 </a:solidFill>
                 <a:latin typeface="Segoe UI" panose="020B0502040204020203" pitchFamily="34" charset="0"/>
               </a:rPr>
-              <a:t>Speaker: Devansh Maini</a:t>
+              <a:t>Speaker: Vaibhav Tank</a:t>
             </a:r>
           </a:p>
         </p:txBody>
@@ -4334,7 +4335,7 @@
           <p:cNvPr id="7" name="TextBox 6">
             <a:extLst>
               <a:ext uri="{FF2B5EF4-FFF2-40B4-BE49-F238E27FC236}">
-                <a16:creationId xmlns:a16="http://schemas.microsoft.com/office/drawing/2014/main" id="{104A311B-219B-5252-C9B1-FB1356D91535}"/>
+                <a16:creationId xmlns:a16="http://schemas.microsoft.com/office/drawing/2014/main" id="{8DB7B2C9-AA2F-F3CA-E74A-1B23DAE652FA}"/>
               </a:ext>
             </a:extLst>
           </p:cNvPr>
@@ -4378,7 +4379,7 @@
           <p:cNvPr id="8" name="TextBox 7">
             <a:extLst>
               <a:ext uri="{FF2B5EF4-FFF2-40B4-BE49-F238E27FC236}">
-                <a16:creationId xmlns:a16="http://schemas.microsoft.com/office/drawing/2014/main" id="{9552F7B0-90A8-83F8-7B6B-F8B16EB54496}"/>
+                <a16:creationId xmlns:a16="http://schemas.microsoft.com/office/drawing/2014/main" id="{ED8211AF-FCDF-3CF3-230C-DC2A1EA7BC8F}"/>
               </a:ext>
             </a:extLst>
           </p:cNvPr>
@@ -4416,7 +4417,7 @@
     </p:spTree>
     <p:extLst>
       <p:ext uri="{BB962C8B-B14F-4D97-AF65-F5344CB8AC3E}">
-        <p14:creationId xmlns:p14="http://schemas.microsoft.com/office/powerpoint/2010/main" val="4243082859"/>
+        <p14:creationId xmlns:p14="http://schemas.microsoft.com/office/powerpoint/2010/main" val="2798590190"/>
       </p:ext>
     </p:extLst>
   </p:cSld>
@@ -4448,7 +4449,7 @@
           <p:cNvPr id="2" name="Rectangle 1">
             <a:extLst>
               <a:ext uri="{FF2B5EF4-FFF2-40B4-BE49-F238E27FC236}">
-                <a16:creationId xmlns:a16="http://schemas.microsoft.com/office/drawing/2014/main" id="{C738803E-E207-877B-0577-3C909EA50E3E}"/>
+                <a16:creationId xmlns:a16="http://schemas.microsoft.com/office/drawing/2014/main" id="{478A28A1-9F38-4069-ECF6-477947871AF7}"/>
               </a:ext>
             </a:extLst>
           </p:cNvPr>
@@ -4516,7 +4517,7 @@
           <p:cNvPr id="3" name="Rectangle 2">
             <a:extLst>
               <a:ext uri="{FF2B5EF4-FFF2-40B4-BE49-F238E27FC236}">
-                <a16:creationId xmlns:a16="http://schemas.microsoft.com/office/drawing/2014/main" id="{E283E03E-BBC2-8C37-F172-22442EB86273}"/>
+                <a16:creationId xmlns:a16="http://schemas.microsoft.com/office/drawing/2014/main" id="{40C22C62-D3F1-751F-A5AE-7F67CA3C176E}"/>
               </a:ext>
             </a:extLst>
           </p:cNvPr>
@@ -4584,7 +4585,7 @@
           <p:cNvPr id="4" name="TextBox 3">
             <a:extLst>
               <a:ext uri="{FF2B5EF4-FFF2-40B4-BE49-F238E27FC236}">
-                <a16:creationId xmlns:a16="http://schemas.microsoft.com/office/drawing/2014/main" id="{E439C7B5-B499-C576-FD86-40D97481B843}"/>
+                <a16:creationId xmlns:a16="http://schemas.microsoft.com/office/drawing/2014/main" id="{785575CD-FCDE-CF3F-90DD-AC370C2203A5}"/>
               </a:ext>
             </a:extLst>
           </p:cNvPr>
@@ -4624,7 +4625,7 @@
           <p:cNvPr id="5" name="TextBox 4">
             <a:extLst>
               <a:ext uri="{FF2B5EF4-FFF2-40B4-BE49-F238E27FC236}">
-                <a16:creationId xmlns:a16="http://schemas.microsoft.com/office/drawing/2014/main" id="{7B508847-1800-9D56-2B22-6FF9E131EC79}"/>
+                <a16:creationId xmlns:a16="http://schemas.microsoft.com/office/drawing/2014/main" id="{31DCB172-F3B4-4101-0C8C-7348170FABE9}"/>
               </a:ext>
             </a:extLst>
           </p:cNvPr>
@@ -4670,7 +4671,7 @@
           <p:cNvPr id="6" name="TextBox 5">
             <a:extLst>
               <a:ext uri="{FF2B5EF4-FFF2-40B4-BE49-F238E27FC236}">
-                <a16:creationId xmlns:a16="http://schemas.microsoft.com/office/drawing/2014/main" id="{CBC8641F-75EF-AC79-5795-D0561049C8DE}"/>
+                <a16:creationId xmlns:a16="http://schemas.microsoft.com/office/drawing/2014/main" id="{A1F49410-7ADA-C5A4-6DED-939A8AA6FD98}"/>
               </a:ext>
             </a:extLst>
           </p:cNvPr>
@@ -4700,7 +4701,7 @@
                 </a:solidFill>
                 <a:latin typeface="Segoe UI" panose="020B0502040204020203" pitchFamily="34" charset="0"/>
               </a:rPr>
-              <a:t>Speaker: Aviral Joshi</a:t>
+              <a:t>Speaker: Rajveer Singh Ranawat</a:t>
             </a:r>
           </a:p>
         </p:txBody>
@@ -4710,7 +4711,7 @@
           <p:cNvPr id="7" name="TextBox 6">
             <a:extLst>
               <a:ext uri="{FF2B5EF4-FFF2-40B4-BE49-F238E27FC236}">
-                <a16:creationId xmlns:a16="http://schemas.microsoft.com/office/drawing/2014/main" id="{D80D8ECE-E358-F904-29F2-78B5015E2B7C}"/>
+                <a16:creationId xmlns:a16="http://schemas.microsoft.com/office/drawing/2014/main" id="{B5043B4A-6064-2A63-1EC6-3410A23D2CE3}"/>
               </a:ext>
             </a:extLst>
           </p:cNvPr>
@@ -4754,7 +4755,7 @@
           <p:cNvPr id="8" name="TextBox 7">
             <a:extLst>
               <a:ext uri="{FF2B5EF4-FFF2-40B4-BE49-F238E27FC236}">
-                <a16:creationId xmlns:a16="http://schemas.microsoft.com/office/drawing/2014/main" id="{7E0A81A8-C2E1-3A5A-2565-0EF8914D40BF}"/>
+                <a16:creationId xmlns:a16="http://schemas.microsoft.com/office/drawing/2014/main" id="{0E5DC62F-4A66-FD22-4177-810371BAA8C2}"/>
               </a:ext>
             </a:extLst>
           </p:cNvPr>
@@ -4792,7 +4793,7 @@
     </p:spTree>
     <p:extLst>
       <p:ext uri="{BB962C8B-B14F-4D97-AF65-F5344CB8AC3E}">
-        <p14:creationId xmlns:p14="http://schemas.microsoft.com/office/powerpoint/2010/main" val="2672886150"/>
+        <p14:creationId xmlns:p14="http://schemas.microsoft.com/office/powerpoint/2010/main" val="3775016959"/>
       </p:ext>
     </p:extLst>
   </p:cSld>
@@ -4824,7 +4825,7 @@
           <p:cNvPr id="2" name="Rectangle 1">
             <a:extLst>
               <a:ext uri="{FF2B5EF4-FFF2-40B4-BE49-F238E27FC236}">
-                <a16:creationId xmlns:a16="http://schemas.microsoft.com/office/drawing/2014/main" id="{C46A7D54-0EBA-7A36-5C9D-3CF3AA58EA46}"/>
+                <a16:creationId xmlns:a16="http://schemas.microsoft.com/office/drawing/2014/main" id="{891B3D7D-5BA5-48E8-4174-B001DDA2CAAA}"/>
               </a:ext>
             </a:extLst>
           </p:cNvPr>
@@ -4892,7 +4893,7 @@
           <p:cNvPr id="3" name="Rectangle 2">
             <a:extLst>
               <a:ext uri="{FF2B5EF4-FFF2-40B4-BE49-F238E27FC236}">
-                <a16:creationId xmlns:a16="http://schemas.microsoft.com/office/drawing/2014/main" id="{54B6E2F3-8AB5-9C23-0BA2-EDBD097A358B}"/>
+                <a16:creationId xmlns:a16="http://schemas.microsoft.com/office/drawing/2014/main" id="{8B558068-A42D-8FC0-75DC-9FFF7D02C5C0}"/>
               </a:ext>
             </a:extLst>
           </p:cNvPr>
@@ -4960,7 +4961,7 @@
           <p:cNvPr id="4" name="TextBox 3">
             <a:extLst>
               <a:ext uri="{FF2B5EF4-FFF2-40B4-BE49-F238E27FC236}">
-                <a16:creationId xmlns:a16="http://schemas.microsoft.com/office/drawing/2014/main" id="{374DE477-B89A-1B8F-6A2E-2B84B9EE8833}"/>
+                <a16:creationId xmlns:a16="http://schemas.microsoft.com/office/drawing/2014/main" id="{F175DD65-4AF0-CF15-46F2-4DFD1EDBCE2F}"/>
               </a:ext>
             </a:extLst>
           </p:cNvPr>
@@ -5006,7 +5007,7 @@
           <p:cNvPr id="5" name="TextBox 4">
             <a:extLst>
               <a:ext uri="{FF2B5EF4-FFF2-40B4-BE49-F238E27FC236}">
-                <a16:creationId xmlns:a16="http://schemas.microsoft.com/office/drawing/2014/main" id="{A683E481-EC72-3466-ACBD-D4D16AB0BD46}"/>
+                <a16:creationId xmlns:a16="http://schemas.microsoft.com/office/drawing/2014/main" id="{2D9662B2-4E5F-737D-3314-18B9881A8D4C}"/>
               </a:ext>
             </a:extLst>
           </p:cNvPr>
@@ -5052,7 +5053,7 @@
           <p:cNvPr id="6" name="TextBox 5">
             <a:extLst>
               <a:ext uri="{FF2B5EF4-FFF2-40B4-BE49-F238E27FC236}">
-                <a16:creationId xmlns:a16="http://schemas.microsoft.com/office/drawing/2014/main" id="{15A85359-A693-1E3C-32DF-394370E19E7A}"/>
+                <a16:creationId xmlns:a16="http://schemas.microsoft.com/office/drawing/2014/main" id="{FF85465F-29C9-6AAD-E80B-646BCE783B88}"/>
               </a:ext>
             </a:extLst>
           </p:cNvPr>
@@ -5082,7 +5083,7 @@
                 </a:solidFill>
                 <a:latin typeface="Segoe UI" panose="020B0502040204020203" pitchFamily="34" charset="0"/>
               </a:rPr>
-              <a:t>Speaker: Aryan Kumar Singh</a:t>
+              <a:t>Speaker: Shaurya Dixit</a:t>
             </a:r>
           </a:p>
         </p:txBody>
@@ -5092,7 +5093,7 @@
           <p:cNvPr id="7" name="TextBox 6">
             <a:extLst>
               <a:ext uri="{FF2B5EF4-FFF2-40B4-BE49-F238E27FC236}">
-                <a16:creationId xmlns:a16="http://schemas.microsoft.com/office/drawing/2014/main" id="{D8E24E4A-53BC-1667-F56F-CBAE660D1770}"/>
+                <a16:creationId xmlns:a16="http://schemas.microsoft.com/office/drawing/2014/main" id="{F34BA6E0-7042-1FC8-44ED-252D1871AF9E}"/>
               </a:ext>
             </a:extLst>
           </p:cNvPr>
@@ -5124,11 +5125,11 @@
               </a:rPr>
               <a:t>[*]  main branch: Production release branch tagged with v1.0.0.
 [*]  develop branch: Integration branch merging all 5 completed features.
-[*]  feature/member1-rag-engine: Aryan Kumar Singh (Lead RAG orchestrator).
-[*]  feature/member2-doc-ingestion: Awantika Jaiswal (Apache Tika and chunker).
-[*]  feature/member3-database-security: Devansh Maini (Neon pgvector and JWT).
-[*]  feature/member4-ui-electron: Aviral Joshi (React and Electron desktop).
-[*]  feature/member5-analytics-evaluation: Akshita Mawaliya (RAG Triad and QA).
+[*]  feature/member1-rag-engine: Shaurya Dixit (Lead RAG orchestrator).
+[*]  feature/member2-doc-ingestion: Yashvardhan Singh Chauhan (Apache Tika and chunker, Kaggle data).
+[*]  feature/member3-database-security: Vaibhav Tank (Neon pgvector and JWT).
+[*]  feature/member4-ui-electron: Rajveer Singh Ranawat (React and Electron desktop).
+[*]  feature/member5-analytics-evaluation: Yashpal Singh Bhati (RAG Triad and QA).
 [*]  Compliance: Minimum 3 commits per student per week verified across all 14 project weeks.</a:t>
             </a:r>
           </a:p>
@@ -5139,7 +5140,7 @@
           <p:cNvPr id="8" name="TextBox 7">
             <a:extLst>
               <a:ext uri="{FF2B5EF4-FFF2-40B4-BE49-F238E27FC236}">
-                <a16:creationId xmlns:a16="http://schemas.microsoft.com/office/drawing/2014/main" id="{C7220425-1D39-88E8-89D9-436997D44A1B}"/>
+                <a16:creationId xmlns:a16="http://schemas.microsoft.com/office/drawing/2014/main" id="{BC9E27E5-1BD4-FB55-4248-839F467E5777}"/>
               </a:ext>
             </a:extLst>
           </p:cNvPr>
@@ -5177,7 +5178,7 @@
     </p:spTree>
     <p:extLst>
       <p:ext uri="{BB962C8B-B14F-4D97-AF65-F5344CB8AC3E}">
-        <p14:creationId xmlns:p14="http://schemas.microsoft.com/office/powerpoint/2010/main" val="4072899435"/>
+        <p14:creationId xmlns:p14="http://schemas.microsoft.com/office/powerpoint/2010/main" val="1199793431"/>
       </p:ext>
     </p:extLst>
   </p:cSld>
@@ -5209,7 +5210,7 @@
           <p:cNvPr id="2" name="Rectangle 1">
             <a:extLst>
               <a:ext uri="{FF2B5EF4-FFF2-40B4-BE49-F238E27FC236}">
-                <a16:creationId xmlns:a16="http://schemas.microsoft.com/office/drawing/2014/main" id="{D9E3340A-5E7E-CDD5-D4C9-4648BB1D1746}"/>
+                <a16:creationId xmlns:a16="http://schemas.microsoft.com/office/drawing/2014/main" id="{769E2365-32CB-2C78-C408-0D1E5A798A21}"/>
               </a:ext>
             </a:extLst>
           </p:cNvPr>
@@ -5277,7 +5278,7 @@
           <p:cNvPr id="3" name="Rectangle 2">
             <a:extLst>
               <a:ext uri="{FF2B5EF4-FFF2-40B4-BE49-F238E27FC236}">
-                <a16:creationId xmlns:a16="http://schemas.microsoft.com/office/drawing/2014/main" id="{D063E527-DC12-2601-B03B-65DAED358FB6}"/>
+                <a16:creationId xmlns:a16="http://schemas.microsoft.com/office/drawing/2014/main" id="{80DAF14D-F479-372C-1FC6-3522D15B40D6}"/>
               </a:ext>
             </a:extLst>
           </p:cNvPr>
@@ -5345,7 +5346,7 @@
           <p:cNvPr id="4" name="TextBox 3">
             <a:extLst>
               <a:ext uri="{FF2B5EF4-FFF2-40B4-BE49-F238E27FC236}">
-                <a16:creationId xmlns:a16="http://schemas.microsoft.com/office/drawing/2014/main" id="{74CD7DF8-3768-F89B-39EC-4293A975F017}"/>
+                <a16:creationId xmlns:a16="http://schemas.microsoft.com/office/drawing/2014/main" id="{C88C46E6-BFEF-5FB7-6FD4-89CCB711013A}"/>
               </a:ext>
             </a:extLst>
           </p:cNvPr>
@@ -5385,7 +5386,7 @@
           <p:cNvPr id="5" name="TextBox 4">
             <a:extLst>
               <a:ext uri="{FF2B5EF4-FFF2-40B4-BE49-F238E27FC236}">
-                <a16:creationId xmlns:a16="http://schemas.microsoft.com/office/drawing/2014/main" id="{46A2A5E2-FBA3-6471-7EB3-99EF66A22DA7}"/>
+                <a16:creationId xmlns:a16="http://schemas.microsoft.com/office/drawing/2014/main" id="{7EA5AE37-1978-4E53-FC4E-3D602078A0ED}"/>
               </a:ext>
             </a:extLst>
           </p:cNvPr>
@@ -5431,7 +5432,7 @@
           <p:cNvPr id="6" name="TextBox 5">
             <a:extLst>
               <a:ext uri="{FF2B5EF4-FFF2-40B4-BE49-F238E27FC236}">
-                <a16:creationId xmlns:a16="http://schemas.microsoft.com/office/drawing/2014/main" id="{F794323F-56FC-D79B-79D3-71356507E269}"/>
+                <a16:creationId xmlns:a16="http://schemas.microsoft.com/office/drawing/2014/main" id="{34A71BA9-1768-5E6C-C673-85402A0AD49D}"/>
               </a:ext>
             </a:extLst>
           </p:cNvPr>
@@ -5461,7 +5462,7 @@
                 </a:solidFill>
                 <a:latin typeface="Segoe UI" panose="020B0502040204020203" pitchFamily="34" charset="0"/>
               </a:rPr>
-              <a:t>Speaker: Aryan Kumar Singh</a:t>
+              <a:t>Speaker: Shaurya Dixit</a:t>
             </a:r>
           </a:p>
         </p:txBody>
@@ -5471,7 +5472,7 @@
           <p:cNvPr id="7" name="TextBox 6">
             <a:extLst>
               <a:ext uri="{FF2B5EF4-FFF2-40B4-BE49-F238E27FC236}">
-                <a16:creationId xmlns:a16="http://schemas.microsoft.com/office/drawing/2014/main" id="{FFF8BED9-40DC-CCDA-4842-99D0E7EBAD98}"/>
+                <a16:creationId xmlns:a16="http://schemas.microsoft.com/office/drawing/2014/main" id="{B2E711B6-7969-EB38-AEB5-9F5B0543524C}"/>
               </a:ext>
             </a:extLst>
           </p:cNvPr>
@@ -5502,7 +5503,7 @@
                 <a:latin typeface="Segoe UI" panose="020B0502040204020203" pitchFamily="34" charset="0"/>
               </a:rPr>
               <a:t>[*]  Eliminated Database Sprawl: Unifies relational business data and vector embeddings in PostgreSQL.
-[*]  Strict Hallucination Elimination: Achieved 92.4% factual groundedness on academic research papers.
+[*]  Strict Hallucination Elimination: Achieved 92.4% factual groundedness on Kaggle research papers.
 [*]  High Throughput &amp; Low Latency: Sub-100ms vector lookup using tuned HNSW cosine indexing.
 [*]  Production-Grade Cross-Platform Client: Packaged desktop installer with native IPC security.</a:t>
             </a:r>
@@ -5514,7 +5515,7 @@
           <p:cNvPr id="8" name="TextBox 7">
             <a:extLst>
               <a:ext uri="{FF2B5EF4-FFF2-40B4-BE49-F238E27FC236}">
-                <a16:creationId xmlns:a16="http://schemas.microsoft.com/office/drawing/2014/main" id="{6A8AE293-C524-8047-F0D7-C811FE74691E}"/>
+                <a16:creationId xmlns:a16="http://schemas.microsoft.com/office/drawing/2014/main" id="{C4391B4F-07CF-6A18-6D30-6260072BAAC4}"/>
               </a:ext>
             </a:extLst>
           </p:cNvPr>
@@ -5552,7 +5553,7 @@
     </p:spTree>
     <p:extLst>
       <p:ext uri="{BB962C8B-B14F-4D97-AF65-F5344CB8AC3E}">
-        <p14:creationId xmlns:p14="http://schemas.microsoft.com/office/powerpoint/2010/main" val="2782611473"/>
+        <p14:creationId xmlns:p14="http://schemas.microsoft.com/office/powerpoint/2010/main" val="4040057903"/>
       </p:ext>
     </p:extLst>
   </p:cSld>
@@ -5584,7 +5585,7 @@
           <p:cNvPr id="2" name="Rectangle 1">
             <a:extLst>
               <a:ext uri="{FF2B5EF4-FFF2-40B4-BE49-F238E27FC236}">
-                <a16:creationId xmlns:a16="http://schemas.microsoft.com/office/drawing/2014/main" id="{F1CEF5D3-508B-9801-2736-7EC95079FF45}"/>
+                <a16:creationId xmlns:a16="http://schemas.microsoft.com/office/drawing/2014/main" id="{3CED4E00-6604-AA6C-8769-24EBBD322413}"/>
               </a:ext>
             </a:extLst>
           </p:cNvPr>
@@ -5652,7 +5653,7 @@
           <p:cNvPr id="3" name="Rectangle 2">
             <a:extLst>
               <a:ext uri="{FF2B5EF4-FFF2-40B4-BE49-F238E27FC236}">
-                <a16:creationId xmlns:a16="http://schemas.microsoft.com/office/drawing/2014/main" id="{FD0F10A8-E755-9906-3AA9-1B97AB2D3876}"/>
+                <a16:creationId xmlns:a16="http://schemas.microsoft.com/office/drawing/2014/main" id="{E5BEA852-13D5-CC47-DDC1-57D70F0BE538}"/>
               </a:ext>
             </a:extLst>
           </p:cNvPr>
@@ -5720,7 +5721,7 @@
           <p:cNvPr id="4" name="TextBox 3">
             <a:extLst>
               <a:ext uri="{FF2B5EF4-FFF2-40B4-BE49-F238E27FC236}">
-                <a16:creationId xmlns:a16="http://schemas.microsoft.com/office/drawing/2014/main" id="{2E41E938-E50D-FD98-7963-CF50C0ACD9C6}"/>
+                <a16:creationId xmlns:a16="http://schemas.microsoft.com/office/drawing/2014/main" id="{490691D3-34F8-C0C4-1C61-8971E61135D7}"/>
               </a:ext>
             </a:extLst>
           </p:cNvPr>
@@ -5766,7 +5767,7 @@
           <p:cNvPr id="5" name="TextBox 4">
             <a:extLst>
               <a:ext uri="{FF2B5EF4-FFF2-40B4-BE49-F238E27FC236}">
-                <a16:creationId xmlns:a16="http://schemas.microsoft.com/office/drawing/2014/main" id="{1A99A2A8-4C3C-E371-D7A0-AEF84E1AFDC1}"/>
+                <a16:creationId xmlns:a16="http://schemas.microsoft.com/office/drawing/2014/main" id="{3921FBE8-A028-6C16-94F5-B15CC2B26514}"/>
               </a:ext>
             </a:extLst>
           </p:cNvPr>
@@ -5812,7 +5813,7 @@
           <p:cNvPr id="6" name="TextBox 5">
             <a:extLst>
               <a:ext uri="{FF2B5EF4-FFF2-40B4-BE49-F238E27FC236}">
-                <a16:creationId xmlns:a16="http://schemas.microsoft.com/office/drawing/2014/main" id="{F9872EA3-E2B9-D14D-15B5-4904A5898291}"/>
+                <a16:creationId xmlns:a16="http://schemas.microsoft.com/office/drawing/2014/main" id="{83E21AD3-687D-49B9-890A-B620752619BA}"/>
               </a:ext>
             </a:extLst>
           </p:cNvPr>
@@ -5858,7 +5859,7 @@
           <p:cNvPr id="7" name="TextBox 6">
             <a:extLst>
               <a:ext uri="{FF2B5EF4-FFF2-40B4-BE49-F238E27FC236}">
-                <a16:creationId xmlns:a16="http://schemas.microsoft.com/office/drawing/2014/main" id="{642D0E23-12A3-6BBC-2ADF-CD95DD73C834}"/>
+                <a16:creationId xmlns:a16="http://schemas.microsoft.com/office/drawing/2014/main" id="{0BE70C49-0C9A-31A6-B8B4-B23CF3327A1D}"/>
               </a:ext>
             </a:extLst>
           </p:cNvPr>
@@ -5891,7 +5892,7 @@
               <a:t>[*]  Arya College of Engineering and I.T., Jaipur - Dept. of Computer Science and Engineering
 [*]  Course: Java Projects (PBL) - 5th Semester (A.Y. 2026-27)
 [*]  Project Guide / Mentor: Er. Ram Babu Buri (Assistant Professor)
-[*]  Team Members: Aryan Kumar Singh, Awantika Jaiswal, Devansh Maini, Aviral Joshi, Akshita Mawaliya
+[*]  Team Members: Shaurya Dixit, Yashvardhan Singh Chauhan, Vaibhav Tank, Rajveer Singh Ranawat, Yashpal Singh Bhati
 [*]  Live Demonstration &amp; Code Review Ready!</a:t>
             </a:r>
           </a:p>
@@ -5902,7 +5903,7 @@
           <p:cNvPr id="8" name="TextBox 7">
             <a:extLst>
               <a:ext uri="{FF2B5EF4-FFF2-40B4-BE49-F238E27FC236}">
-                <a16:creationId xmlns:a16="http://schemas.microsoft.com/office/drawing/2014/main" id="{BA5D6AB3-204E-DB0F-F9D8-8068BC5357E2}"/>
+                <a16:creationId xmlns:a16="http://schemas.microsoft.com/office/drawing/2014/main" id="{0DEF422D-4680-A92F-C330-F62AC1B5BC78}"/>
               </a:ext>
             </a:extLst>
           </p:cNvPr>
@@ -5940,7 +5941,7 @@
     </p:spTree>
     <p:extLst>
       <p:ext uri="{BB962C8B-B14F-4D97-AF65-F5344CB8AC3E}">
-        <p14:creationId xmlns:p14="http://schemas.microsoft.com/office/powerpoint/2010/main" val="2316563686"/>
+        <p14:creationId xmlns:p14="http://schemas.microsoft.com/office/powerpoint/2010/main" val="2269861405"/>
       </p:ext>
     </p:extLst>
   </p:cSld>
@@ -5972,7 +5973,7 @@
           <p:cNvPr id="2" name="Rectangle 1">
             <a:extLst>
               <a:ext uri="{FF2B5EF4-FFF2-40B4-BE49-F238E27FC236}">
-                <a16:creationId xmlns:a16="http://schemas.microsoft.com/office/drawing/2014/main" id="{933DB6FE-7935-2CEB-16AA-0E61AA1D2552}"/>
+                <a16:creationId xmlns:a16="http://schemas.microsoft.com/office/drawing/2014/main" id="{FA0DE8A4-CCD8-CA47-5F4A-0384521DDFFF}"/>
               </a:ext>
             </a:extLst>
           </p:cNvPr>
@@ -6040,7 +6041,7 @@
           <p:cNvPr id="3" name="Rectangle 2">
             <a:extLst>
               <a:ext uri="{FF2B5EF4-FFF2-40B4-BE49-F238E27FC236}">
-                <a16:creationId xmlns:a16="http://schemas.microsoft.com/office/drawing/2014/main" id="{57216A95-670A-0B40-D1F2-FBCEB7F609CF}"/>
+                <a16:creationId xmlns:a16="http://schemas.microsoft.com/office/drawing/2014/main" id="{931A7F51-2ACC-DDB0-EA31-D44446BB9B12}"/>
               </a:ext>
             </a:extLst>
           </p:cNvPr>
@@ -6108,7 +6109,7 @@
           <p:cNvPr id="4" name="TextBox 3">
             <a:extLst>
               <a:ext uri="{FF2B5EF4-FFF2-40B4-BE49-F238E27FC236}">
-                <a16:creationId xmlns:a16="http://schemas.microsoft.com/office/drawing/2014/main" id="{1144E094-2959-9ED6-F0A6-9D98C3590053}"/>
+                <a16:creationId xmlns:a16="http://schemas.microsoft.com/office/drawing/2014/main" id="{F5D249C8-7435-76C4-94D3-1441A2F1D640}"/>
               </a:ext>
             </a:extLst>
           </p:cNvPr>
@@ -6148,7 +6149,7 @@
           <p:cNvPr id="5" name="TextBox 4">
             <a:extLst>
               <a:ext uri="{FF2B5EF4-FFF2-40B4-BE49-F238E27FC236}">
-                <a16:creationId xmlns:a16="http://schemas.microsoft.com/office/drawing/2014/main" id="{C2CAB54E-1646-63B1-4BE9-D9DA76E347B2}"/>
+                <a16:creationId xmlns:a16="http://schemas.microsoft.com/office/drawing/2014/main" id="{986A7AA1-8FE0-0368-E427-0E73A53FE814}"/>
               </a:ext>
             </a:extLst>
           </p:cNvPr>
@@ -6194,7 +6195,7 @@
           <p:cNvPr id="6" name="TextBox 5">
             <a:extLst>
               <a:ext uri="{FF2B5EF4-FFF2-40B4-BE49-F238E27FC236}">
-                <a16:creationId xmlns:a16="http://schemas.microsoft.com/office/drawing/2014/main" id="{C890F54C-56FC-3810-D7B7-31426F2AB978}"/>
+                <a16:creationId xmlns:a16="http://schemas.microsoft.com/office/drawing/2014/main" id="{5E265BC0-BAEC-C8A1-24EA-AD427DA36F3A}"/>
               </a:ext>
             </a:extLst>
           </p:cNvPr>
@@ -6224,7 +6225,7 @@
                 </a:solidFill>
                 <a:latin typeface="Segoe UI" panose="020B0502040204020203" pitchFamily="34" charset="0"/>
               </a:rPr>
-              <a:t>Speaker: Aryan Kumar Singh</a:t>
+              <a:t>Speaker: Shaurya Dixit</a:t>
             </a:r>
           </a:p>
         </p:txBody>
@@ -6234,7 +6235,7 @@
           <p:cNvPr id="7" name="TextBox 6">
             <a:extLst>
               <a:ext uri="{FF2B5EF4-FFF2-40B4-BE49-F238E27FC236}">
-                <a16:creationId xmlns:a16="http://schemas.microsoft.com/office/drawing/2014/main" id="{11810CA6-8A26-E5A9-79DB-3970B2DCDA67}"/>
+                <a16:creationId xmlns:a16="http://schemas.microsoft.com/office/drawing/2014/main" id="{0B8D6DD0-9D6B-6C35-4C7F-F59A85B33943}"/>
               </a:ext>
             </a:extLst>
           </p:cNvPr>
@@ -6265,9 +6266,9 @@
                 <a:latin typeface="Segoe UI" panose="020B0502040204020203" pitchFamily="34" charset="0"/>
               </a:rPr>
               <a:t>[*]  Hallucination Risk: Foundation LLMs fabricate convincing but false facts on domain-specific corpora.
-[*]  Knowledge Cutoff: Pre-trained models cannot access newly released syllabi, papers, or local university guidelines.
-[*]  Keyword Search Inadequacy: Traditional keyword engines miss semantic and conceptual context.
-[*]  Enterprise Privacy: Academic institutions require strict private on-premise or sovereign cloud hosting.</a:t>
+[*]  Knowledge Cutoff: Pre-trained models cannot access newly released research papers or internal institution documents.
+[*]  Keyword Search Inadequacy: Traditional keyword engines miss semantic and conceptual context in research literature.
+[*]  Academic Data Grounding: Evaluating RAG on Kaggle academic research paper datasets requires deterministic verification.</a:t>
             </a:r>
             <a:endParaRPr lang="en-IN" sz="1500">
               <a:solidFill>
@@ -6283,7 +6284,7 @@
           <p:cNvPr id="8" name="TextBox 7">
             <a:extLst>
               <a:ext uri="{FF2B5EF4-FFF2-40B4-BE49-F238E27FC236}">
-                <a16:creationId xmlns:a16="http://schemas.microsoft.com/office/drawing/2014/main" id="{CA5DF927-C7F2-AE02-D0B6-8B7930B69FE8}"/>
+                <a16:creationId xmlns:a16="http://schemas.microsoft.com/office/drawing/2014/main" id="{7441E5DE-5DE0-65FF-7DB4-D2AA3E47E5D8}"/>
               </a:ext>
             </a:extLst>
           </p:cNvPr>
@@ -6321,7 +6322,7 @@
     </p:spTree>
     <p:extLst>
       <p:ext uri="{BB962C8B-B14F-4D97-AF65-F5344CB8AC3E}">
-        <p14:creationId xmlns:p14="http://schemas.microsoft.com/office/powerpoint/2010/main" val="1407436815"/>
+        <p14:creationId xmlns:p14="http://schemas.microsoft.com/office/powerpoint/2010/main" val="2368183088"/>
       </p:ext>
     </p:extLst>
   </p:cSld>
@@ -6353,7 +6354,7 @@
           <p:cNvPr id="2" name="Rectangle 1">
             <a:extLst>
               <a:ext uri="{FF2B5EF4-FFF2-40B4-BE49-F238E27FC236}">
-                <a16:creationId xmlns:a16="http://schemas.microsoft.com/office/drawing/2014/main" id="{CD80B635-C71F-067F-7A56-FD8F3F7DE51E}"/>
+                <a16:creationId xmlns:a16="http://schemas.microsoft.com/office/drawing/2014/main" id="{EB2884F1-8F14-EBD5-78C9-C392153A04A1}"/>
               </a:ext>
             </a:extLst>
           </p:cNvPr>
@@ -6421,7 +6422,7 @@
           <p:cNvPr id="3" name="Rectangle 2">
             <a:extLst>
               <a:ext uri="{FF2B5EF4-FFF2-40B4-BE49-F238E27FC236}">
-                <a16:creationId xmlns:a16="http://schemas.microsoft.com/office/drawing/2014/main" id="{5CA6DAEE-112F-63E4-828E-1A6CF34562F1}"/>
+                <a16:creationId xmlns:a16="http://schemas.microsoft.com/office/drawing/2014/main" id="{6B396013-3BAC-BE97-E85D-E8D89A27FC50}"/>
               </a:ext>
             </a:extLst>
           </p:cNvPr>
@@ -6489,7 +6490,7 @@
           <p:cNvPr id="4" name="TextBox 3">
             <a:extLst>
               <a:ext uri="{FF2B5EF4-FFF2-40B4-BE49-F238E27FC236}">
-                <a16:creationId xmlns:a16="http://schemas.microsoft.com/office/drawing/2014/main" id="{EC70F391-038A-89DD-52B7-9E9F9FA34BC6}"/>
+                <a16:creationId xmlns:a16="http://schemas.microsoft.com/office/drawing/2014/main" id="{3CF3AFA8-4CC9-EB0F-085E-D19CA0FB0A71}"/>
               </a:ext>
             </a:extLst>
           </p:cNvPr>
@@ -6529,7 +6530,7 @@
           <p:cNvPr id="5" name="TextBox 4">
             <a:extLst>
               <a:ext uri="{FF2B5EF4-FFF2-40B4-BE49-F238E27FC236}">
-                <a16:creationId xmlns:a16="http://schemas.microsoft.com/office/drawing/2014/main" id="{52C40D30-E92F-1F57-1D76-D7F61FCCC634}"/>
+                <a16:creationId xmlns:a16="http://schemas.microsoft.com/office/drawing/2014/main" id="{BC9C895A-46BB-88BB-0476-85FA19A210EF}"/>
               </a:ext>
             </a:extLst>
           </p:cNvPr>
@@ -6569,7 +6570,7 @@
           <p:cNvPr id="6" name="TextBox 5">
             <a:extLst>
               <a:ext uri="{FF2B5EF4-FFF2-40B4-BE49-F238E27FC236}">
-                <a16:creationId xmlns:a16="http://schemas.microsoft.com/office/drawing/2014/main" id="{5B6727F0-D711-2F6F-1C30-E874FEBDE614}"/>
+                <a16:creationId xmlns:a16="http://schemas.microsoft.com/office/drawing/2014/main" id="{BC72CB5F-02B4-BEB3-C09B-0342BED87AA6}"/>
               </a:ext>
             </a:extLst>
           </p:cNvPr>
@@ -6599,7 +6600,7 @@
                 </a:solidFill>
                 <a:latin typeface="Segoe UI" panose="020B0502040204020203" pitchFamily="34" charset="0"/>
               </a:rPr>
-              <a:t>Speaker: Aryan Kumar Singh</a:t>
+              <a:t>Speaker: Shaurya Dixit</a:t>
             </a:r>
           </a:p>
         </p:txBody>
@@ -6609,7 +6610,7 @@
           <p:cNvPr id="7" name="TextBox 6">
             <a:extLst>
               <a:ext uri="{FF2B5EF4-FFF2-40B4-BE49-F238E27FC236}">
-                <a16:creationId xmlns:a16="http://schemas.microsoft.com/office/drawing/2014/main" id="{E46D79B0-43CA-97F6-53AC-F1A6607D073B}"/>
+                <a16:creationId xmlns:a16="http://schemas.microsoft.com/office/drawing/2014/main" id="{10D89678-25CD-7E73-1EED-7DC3608073DF}"/>
               </a:ext>
             </a:extLst>
           </p:cNvPr>
@@ -6639,7 +6640,7 @@
                 </a:solidFill>
                 <a:latin typeface="Segoe UI" panose="020B0502040204020203" pitchFamily="34" charset="0"/>
               </a:rPr>
-              <a:t>[*]  Java Spring Boot 3 Backend: Type-safe, high-throughput microservice handling retrieval and streaming.
+              <a:t>[*]  Java Spring Boot 3 Backend: Type-safe, high-throughput microservice handling retrieval, chunking, and streaming.
 [*]  Neon PostgreSQL with pgvector: Unified relational and vector database with sub-100ms HNSW cosine lookups.
 [*]  Electron + React 18 Desktop Shell: Cross-platform desktop interface with native IPC and drag-and-drop ingestion.
 [*]  Automated RAG Triad Evaluation: Real-time scoring of Context Relevance, Faithfulness, and Answer Relevance.</a:t>
@@ -6652,7 +6653,7 @@
           <p:cNvPr id="8" name="TextBox 7">
             <a:extLst>
               <a:ext uri="{FF2B5EF4-FFF2-40B4-BE49-F238E27FC236}">
-                <a16:creationId xmlns:a16="http://schemas.microsoft.com/office/drawing/2014/main" id="{7E815715-3CAF-1004-3133-308E4C9C9F9F}"/>
+                <a16:creationId xmlns:a16="http://schemas.microsoft.com/office/drawing/2014/main" id="{8AD819D0-0390-156A-EA7F-3C72C2CFA8FD}"/>
               </a:ext>
             </a:extLst>
           </p:cNvPr>
@@ -6690,7 +6691,7 @@
     </p:spTree>
     <p:extLst>
       <p:ext uri="{BB962C8B-B14F-4D97-AF65-F5344CB8AC3E}">
-        <p14:creationId xmlns:p14="http://schemas.microsoft.com/office/powerpoint/2010/main" val="738086745"/>
+        <p14:creationId xmlns:p14="http://schemas.microsoft.com/office/powerpoint/2010/main" val="2664206033"/>
       </p:ext>
     </p:extLst>
   </p:cSld>
@@ -6722,7 +6723,7 @@
           <p:cNvPr id="2" name="Rectangle 1">
             <a:extLst>
               <a:ext uri="{FF2B5EF4-FFF2-40B4-BE49-F238E27FC236}">
-                <a16:creationId xmlns:a16="http://schemas.microsoft.com/office/drawing/2014/main" id="{76CEDA60-802A-63A4-80AB-C3124A360843}"/>
+                <a16:creationId xmlns:a16="http://schemas.microsoft.com/office/drawing/2014/main" id="{90320221-7AB1-E592-5FCF-17B0D47B8707}"/>
               </a:ext>
             </a:extLst>
           </p:cNvPr>
@@ -6790,7 +6791,7 @@
           <p:cNvPr id="3" name="Rectangle 2">
             <a:extLst>
               <a:ext uri="{FF2B5EF4-FFF2-40B4-BE49-F238E27FC236}">
-                <a16:creationId xmlns:a16="http://schemas.microsoft.com/office/drawing/2014/main" id="{25918C19-6AEE-E21A-7C6B-5DF6CFE0B07B}"/>
+                <a16:creationId xmlns:a16="http://schemas.microsoft.com/office/drawing/2014/main" id="{421281DD-B6FE-D89D-BF8E-40CA430A182D}"/>
               </a:ext>
             </a:extLst>
           </p:cNvPr>
@@ -6858,7 +6859,7 @@
           <p:cNvPr id="4" name="TextBox 3">
             <a:extLst>
               <a:ext uri="{FF2B5EF4-FFF2-40B4-BE49-F238E27FC236}">
-                <a16:creationId xmlns:a16="http://schemas.microsoft.com/office/drawing/2014/main" id="{4DDA6190-DF55-6F20-A388-B4F4B945F48E}"/>
+                <a16:creationId xmlns:a16="http://schemas.microsoft.com/office/drawing/2014/main" id="{C20177DF-B597-3603-08BF-C293EEE05B4E}"/>
               </a:ext>
             </a:extLst>
           </p:cNvPr>
@@ -6898,7 +6899,7 @@
           <p:cNvPr id="5" name="TextBox 4">
             <a:extLst>
               <a:ext uri="{FF2B5EF4-FFF2-40B4-BE49-F238E27FC236}">
-                <a16:creationId xmlns:a16="http://schemas.microsoft.com/office/drawing/2014/main" id="{87C5B9BE-0466-ABDC-0AA2-7E2A9E4734E7}"/>
+                <a16:creationId xmlns:a16="http://schemas.microsoft.com/office/drawing/2014/main" id="{12BC0AAD-0C6F-058F-F91E-B4BF22E65EF7}"/>
               </a:ext>
             </a:extLst>
           </p:cNvPr>
@@ -6944,7 +6945,7 @@
           <p:cNvPr id="6" name="TextBox 5">
             <a:extLst>
               <a:ext uri="{FF2B5EF4-FFF2-40B4-BE49-F238E27FC236}">
-                <a16:creationId xmlns:a16="http://schemas.microsoft.com/office/drawing/2014/main" id="{E985FDB2-A3C8-1CA2-041B-AECF5AB374AC}"/>
+                <a16:creationId xmlns:a16="http://schemas.microsoft.com/office/drawing/2014/main" id="{EC1351F3-74EB-3EB3-2512-CC20B2B5B3EA}"/>
               </a:ext>
             </a:extLst>
           </p:cNvPr>
@@ -6974,7 +6975,7 @@
                 </a:solidFill>
                 <a:latin typeface="Segoe UI" panose="020B0502040204020203" pitchFamily="34" charset="0"/>
               </a:rPr>
-              <a:t>Speaker: Aryan Kumar Singh</a:t>
+              <a:t>Speaker: Shaurya Dixit</a:t>
             </a:r>
           </a:p>
         </p:txBody>
@@ -6984,7 +6985,7 @@
           <p:cNvPr id="7" name="TextBox 6">
             <a:extLst>
               <a:ext uri="{FF2B5EF4-FFF2-40B4-BE49-F238E27FC236}">
-                <a16:creationId xmlns:a16="http://schemas.microsoft.com/office/drawing/2014/main" id="{B90EC0AE-6E8B-CCD3-937F-0115255361C1}"/>
+                <a16:creationId xmlns:a16="http://schemas.microsoft.com/office/drawing/2014/main" id="{FC29B250-8361-9886-144B-DC38A3698D76}"/>
               </a:ext>
             </a:extLst>
           </p:cNvPr>
@@ -7014,7 +7015,7 @@
                 </a:solidFill>
                 <a:latin typeface="Segoe UI" panose="020B0502040204020203" pitchFamily="34" charset="0"/>
               </a:rPr>
-              <a:t>[*]  Step 1: User submits query via Electron Desktop UI (/api/rag/chat).
+              <a:t>[*]  Step 1: User submits query via Electron Desktop UI or Web interface (/api/rag/chat).
 [*]  Step 2: Spring Security validates JWT token and Bucket4j enforces rate limits.
 [*]  Step 3: Query is converted to 1536-dimensional dense embedding vector.
 [*]  Step 4: Neon PostgreSQL executes HNSW cosine distance search returning Top-4 chunks in under 94ms.
@@ -7029,7 +7030,7 @@
           <p:cNvPr id="8" name="TextBox 7">
             <a:extLst>
               <a:ext uri="{FF2B5EF4-FFF2-40B4-BE49-F238E27FC236}">
-                <a16:creationId xmlns:a16="http://schemas.microsoft.com/office/drawing/2014/main" id="{396FA4FB-65A2-628E-89AC-BFB9876174FD}"/>
+                <a16:creationId xmlns:a16="http://schemas.microsoft.com/office/drawing/2014/main" id="{94D35DD4-79F0-1C26-74D0-0B5D84AF9241}"/>
               </a:ext>
             </a:extLst>
           </p:cNvPr>
@@ -7067,7 +7068,7 @@
     </p:spTree>
     <p:extLst>
       <p:ext uri="{BB962C8B-B14F-4D97-AF65-F5344CB8AC3E}">
-        <p14:creationId xmlns:p14="http://schemas.microsoft.com/office/powerpoint/2010/main" val="2667179309"/>
+        <p14:creationId xmlns:p14="http://schemas.microsoft.com/office/powerpoint/2010/main" val="1737275823"/>
       </p:ext>
     </p:extLst>
   </p:cSld>
@@ -7099,7 +7100,7 @@
           <p:cNvPr id="2" name="Rectangle 1">
             <a:extLst>
               <a:ext uri="{FF2B5EF4-FFF2-40B4-BE49-F238E27FC236}">
-                <a16:creationId xmlns:a16="http://schemas.microsoft.com/office/drawing/2014/main" id="{C34FA5A3-3A73-6B6B-AD37-4B853CF93447}"/>
+                <a16:creationId xmlns:a16="http://schemas.microsoft.com/office/drawing/2014/main" id="{F6E5B757-3288-8BD5-C1A6-8B103DDE456C}"/>
               </a:ext>
             </a:extLst>
           </p:cNvPr>
@@ -7167,7 +7168,7 @@
           <p:cNvPr id="3" name="Rectangle 2">
             <a:extLst>
               <a:ext uri="{FF2B5EF4-FFF2-40B4-BE49-F238E27FC236}">
-                <a16:creationId xmlns:a16="http://schemas.microsoft.com/office/drawing/2014/main" id="{5728AFFB-F03B-451D-DE3F-9386A66E559F}"/>
+                <a16:creationId xmlns:a16="http://schemas.microsoft.com/office/drawing/2014/main" id="{E05CAFC7-CB36-FAC3-9FA6-9365D2247769}"/>
               </a:ext>
             </a:extLst>
           </p:cNvPr>
@@ -7235,7 +7236,7 @@
           <p:cNvPr id="4" name="TextBox 3">
             <a:extLst>
               <a:ext uri="{FF2B5EF4-FFF2-40B4-BE49-F238E27FC236}">
-                <a16:creationId xmlns:a16="http://schemas.microsoft.com/office/drawing/2014/main" id="{6A3B4B1D-CCA7-9C57-47F7-99C1CDB37C0F}"/>
+                <a16:creationId xmlns:a16="http://schemas.microsoft.com/office/drawing/2014/main" id="{F2F94604-71AD-D8B2-D69B-20EAD851311C}"/>
               </a:ext>
             </a:extLst>
           </p:cNvPr>
@@ -7281,7 +7282,7 @@
           <p:cNvPr id="5" name="TextBox 4">
             <a:extLst>
               <a:ext uri="{FF2B5EF4-FFF2-40B4-BE49-F238E27FC236}">
-                <a16:creationId xmlns:a16="http://schemas.microsoft.com/office/drawing/2014/main" id="{3D74863C-3FB0-4AE6-56F9-99578D2DBDE1}"/>
+                <a16:creationId xmlns:a16="http://schemas.microsoft.com/office/drawing/2014/main" id="{3524EE6C-9E20-149D-BEA9-24A5A649A662}"/>
               </a:ext>
             </a:extLst>
           </p:cNvPr>
@@ -7311,7 +7312,7 @@
                 </a:solidFill>
                 <a:latin typeface="Segoe UI" panose="020B0502040204020203" pitchFamily="34" charset="0"/>
               </a:rPr>
-              <a:t>Owner: Aryan Kumar Singh (Team Leader) | Branch: feature/member1-rag-engine</a:t>
+              <a:t>Owner: Shaurya Dixit (Team Leader) | Branch: feature/member1-rag-engine</a:t>
             </a:r>
             <a:endParaRPr lang="en-IN" sz="1300">
               <a:solidFill>
@@ -7327,7 +7328,7 @@
           <p:cNvPr id="6" name="TextBox 5">
             <a:extLst>
               <a:ext uri="{FF2B5EF4-FFF2-40B4-BE49-F238E27FC236}">
-                <a16:creationId xmlns:a16="http://schemas.microsoft.com/office/drawing/2014/main" id="{EDB9E3CF-BD08-40F4-F388-79AC9E774E25}"/>
+                <a16:creationId xmlns:a16="http://schemas.microsoft.com/office/drawing/2014/main" id="{44EEF28F-A8E0-C197-7466-9799FEDE7D53}"/>
               </a:ext>
             </a:extLst>
           </p:cNvPr>
@@ -7351,20 +7352,14 @@
           <a:lstStyle/>
           <a:p>
             <a:r>
-              <a:rPr lang="en-US" sz="1200" b="1">
+              <a:rPr lang="en-IN" sz="1200" b="1">
                 <a:solidFill>
                   <a:srgbClr val="A855F7"/>
                 </a:solidFill>
                 <a:latin typeface="Segoe UI" panose="020B0502040204020203" pitchFamily="34" charset="0"/>
               </a:rPr>
-              <a:t>Speaker: Aryan Kumar Singh (Lead)</a:t>
-            </a:r>
-            <a:endParaRPr lang="en-IN" sz="1200" b="1">
-              <a:solidFill>
-                <a:srgbClr val="A855F7"/>
-              </a:solidFill>
-              <a:latin typeface="Segoe UI" panose="020B0502040204020203" pitchFamily="34" charset="0"/>
-            </a:endParaRPr>
+              <a:t>Speaker: Shaurya Dixit (Lead)</a:t>
+            </a:r>
           </a:p>
         </p:txBody>
       </p:sp>
@@ -7373,7 +7368,7 @@
           <p:cNvPr id="7" name="TextBox 6">
             <a:extLst>
               <a:ext uri="{FF2B5EF4-FFF2-40B4-BE49-F238E27FC236}">
-                <a16:creationId xmlns:a16="http://schemas.microsoft.com/office/drawing/2014/main" id="{E2ED24C5-2515-DC76-E45C-4051509F04EB}"/>
+                <a16:creationId xmlns:a16="http://schemas.microsoft.com/office/drawing/2014/main" id="{82B524E4-8614-1A66-A9AB-AA26E452E0D9}"/>
               </a:ext>
             </a:extLst>
           </p:cNvPr>
@@ -7417,7 +7412,7 @@
           <p:cNvPr id="8" name="TextBox 7">
             <a:extLst>
               <a:ext uri="{FF2B5EF4-FFF2-40B4-BE49-F238E27FC236}">
-                <a16:creationId xmlns:a16="http://schemas.microsoft.com/office/drawing/2014/main" id="{34E2380E-E34B-7DC8-9DE3-C690D6D46FAE}"/>
+                <a16:creationId xmlns:a16="http://schemas.microsoft.com/office/drawing/2014/main" id="{69AED7DF-0312-19CA-1CA5-2821857620F3}"/>
               </a:ext>
             </a:extLst>
           </p:cNvPr>
@@ -7455,7 +7450,7 @@
     </p:spTree>
     <p:extLst>
       <p:ext uri="{BB962C8B-B14F-4D97-AF65-F5344CB8AC3E}">
-        <p14:creationId xmlns:p14="http://schemas.microsoft.com/office/powerpoint/2010/main" val="1621595167"/>
+        <p14:creationId xmlns:p14="http://schemas.microsoft.com/office/powerpoint/2010/main" val="205833401"/>
       </p:ext>
     </p:extLst>
   </p:cSld>
@@ -7487,7 +7482,7 @@
           <p:cNvPr id="2" name="Rectangle 1">
             <a:extLst>
               <a:ext uri="{FF2B5EF4-FFF2-40B4-BE49-F238E27FC236}">
-                <a16:creationId xmlns:a16="http://schemas.microsoft.com/office/drawing/2014/main" id="{1F450EA8-12D4-FBA8-DA3C-D51F1E32EB1C}"/>
+                <a16:creationId xmlns:a16="http://schemas.microsoft.com/office/drawing/2014/main" id="{2630AA69-D69E-55C8-3FDF-5AE1AC0A0CE7}"/>
               </a:ext>
             </a:extLst>
           </p:cNvPr>
@@ -7555,7 +7550,7 @@
           <p:cNvPr id="3" name="Rectangle 2">
             <a:extLst>
               <a:ext uri="{FF2B5EF4-FFF2-40B4-BE49-F238E27FC236}">
-                <a16:creationId xmlns:a16="http://schemas.microsoft.com/office/drawing/2014/main" id="{9F07ADEB-F47F-42A0-FB3C-A26801A219D7}"/>
+                <a16:creationId xmlns:a16="http://schemas.microsoft.com/office/drawing/2014/main" id="{7E914ACC-4626-B8D1-4DD9-F09E2E01B055}"/>
               </a:ext>
             </a:extLst>
           </p:cNvPr>
@@ -7623,7 +7618,7 @@
           <p:cNvPr id="4" name="TextBox 3">
             <a:extLst>
               <a:ext uri="{FF2B5EF4-FFF2-40B4-BE49-F238E27FC236}">
-                <a16:creationId xmlns:a16="http://schemas.microsoft.com/office/drawing/2014/main" id="{3E4ED942-516F-00B6-C9C3-B258D1EDEA9C}"/>
+                <a16:creationId xmlns:a16="http://schemas.microsoft.com/office/drawing/2014/main" id="{815E930E-E04B-EA7F-070C-79A704A2DE68}"/>
               </a:ext>
             </a:extLst>
           </p:cNvPr>
@@ -7663,7 +7658,7 @@
           <p:cNvPr id="5" name="TextBox 4">
             <a:extLst>
               <a:ext uri="{FF2B5EF4-FFF2-40B4-BE49-F238E27FC236}">
-                <a16:creationId xmlns:a16="http://schemas.microsoft.com/office/drawing/2014/main" id="{9E22DD27-38A9-2A57-2B3E-0E23D00BB227}"/>
+                <a16:creationId xmlns:a16="http://schemas.microsoft.com/office/drawing/2014/main" id="{64632D66-C6FE-6BB0-E452-657578A4C93B}"/>
               </a:ext>
             </a:extLst>
           </p:cNvPr>
@@ -7687,20 +7682,14 @@
           <a:lstStyle/>
           <a:p>
             <a:r>
-              <a:rPr lang="en-US" sz="1300">
+              <a:rPr lang="en-IN" sz="1300">
                 <a:solidFill>
                   <a:srgbClr val="94A3B8"/>
                 </a:solidFill>
                 <a:latin typeface="Segoe UI" panose="020B0502040204020203" pitchFamily="34" charset="0"/>
               </a:rPr>
-              <a:t>Owner: Awantika Jaiswal | Branch: feature/member2-doc-ingestion</a:t>
-            </a:r>
-            <a:endParaRPr lang="en-IN" sz="1300">
-              <a:solidFill>
-                <a:srgbClr val="94A3B8"/>
-              </a:solidFill>
-              <a:latin typeface="Segoe UI" panose="020B0502040204020203" pitchFamily="34" charset="0"/>
-            </a:endParaRPr>
+              <a:t>Owner: Yashvardhan Singh Chauhan | Branch: feature/member2-doc-ingestion</a:t>
+            </a:r>
           </a:p>
         </p:txBody>
       </p:sp>
@@ -7709,7 +7698,7 @@
           <p:cNvPr id="6" name="TextBox 5">
             <a:extLst>
               <a:ext uri="{FF2B5EF4-FFF2-40B4-BE49-F238E27FC236}">
-                <a16:creationId xmlns:a16="http://schemas.microsoft.com/office/drawing/2014/main" id="{16AE54DF-910E-5AC8-5AB0-949A206A66DF}"/>
+                <a16:creationId xmlns:a16="http://schemas.microsoft.com/office/drawing/2014/main" id="{399FD346-B055-0057-AD11-91F7B82E90A2}"/>
               </a:ext>
             </a:extLst>
           </p:cNvPr>
@@ -7739,7 +7728,7 @@
                 </a:solidFill>
                 <a:latin typeface="Segoe UI" panose="020B0502040204020203" pitchFamily="34" charset="0"/>
               </a:rPr>
-              <a:t>Speaker: Awantika Jaiswal</a:t>
+              <a:t>Speaker: Yashvardhan Singh Chauhan</a:t>
             </a:r>
           </a:p>
         </p:txBody>
@@ -7749,7 +7738,7 @@
           <p:cNvPr id="7" name="TextBox 6">
             <a:extLst>
               <a:ext uri="{FF2B5EF4-FFF2-40B4-BE49-F238E27FC236}">
-                <a16:creationId xmlns:a16="http://schemas.microsoft.com/office/drawing/2014/main" id="{6C59F32F-EBC5-7BA6-D7D0-91278C52FF30}"/>
+                <a16:creationId xmlns:a16="http://schemas.microsoft.com/office/drawing/2014/main" id="{CE20CDEC-4C75-E4FF-5706-0C89A509E806}"/>
               </a:ext>
             </a:extLst>
           </p:cNvPr>
@@ -7779,11 +7768,11 @@
                 </a:solidFill>
                 <a:latin typeface="Segoe UI" panose="020B0502040204020203" pitchFamily="34" charset="0"/>
               </a:rPr>
-              <a:t>[*]  Multi-Format Extraction: Apache Tika and PDFBox 3 parse PDF, DOCX, TXT, and Markdown up to 25MB.
+              <a:t>[*]  Kaggle Dataset Curation: Ingestion of academic research papers, syllabi, and technical reports (PDF, DOCX, TXT).
+[*]  Multi-Format Extraction: Apache Tika 2.9 and PDFBox 3 parse documents up to 25MB.
 [*]  Recursive Sliding-Window Chunker: 500-token window with 50-token overlap.
 [*]  Sentence Boundary Preservation: Java BreakIterator prevents breaking sentences across chunk boundaries.
-[*]  Asynchronous Task Queue: Spring @Async ThreadPoolTaskExecutor prevents UI blocking.
-[*]  Document Lifecycle Status: Real-time state transitions (UPLOADED -&gt; PARSING -&gt; CHUNKED -&gt; INDEXED).</a:t>
+[*]  Asynchronous Task Queue: Spring @Async ThreadPoolTaskExecutor prevents UI blocking.</a:t>
             </a:r>
           </a:p>
         </p:txBody>
@@ -7793,7 +7782,7 @@
           <p:cNvPr id="8" name="TextBox 7">
             <a:extLst>
               <a:ext uri="{FF2B5EF4-FFF2-40B4-BE49-F238E27FC236}">
-                <a16:creationId xmlns:a16="http://schemas.microsoft.com/office/drawing/2014/main" id="{B2AF5A22-EAB6-1A5D-BC46-AA7812C8E24C}"/>
+                <a16:creationId xmlns:a16="http://schemas.microsoft.com/office/drawing/2014/main" id="{B36B3F8B-5694-16CF-182D-2996E334D296}"/>
               </a:ext>
             </a:extLst>
           </p:cNvPr>
@@ -7831,7 +7820,7 @@
     </p:spTree>
     <p:extLst>
       <p:ext uri="{BB962C8B-B14F-4D97-AF65-F5344CB8AC3E}">
-        <p14:creationId xmlns:p14="http://schemas.microsoft.com/office/powerpoint/2010/main" val="918627081"/>
+        <p14:creationId xmlns:p14="http://schemas.microsoft.com/office/powerpoint/2010/main" val="2626898119"/>
       </p:ext>
     </p:extLst>
   </p:cSld>
@@ -7863,7 +7852,7 @@
           <p:cNvPr id="2" name="Rectangle 1">
             <a:extLst>
               <a:ext uri="{FF2B5EF4-FFF2-40B4-BE49-F238E27FC236}">
-                <a16:creationId xmlns:a16="http://schemas.microsoft.com/office/drawing/2014/main" id="{8A6BAF3B-A185-F7D7-45F0-38EBDA02DD47}"/>
+                <a16:creationId xmlns:a16="http://schemas.microsoft.com/office/drawing/2014/main" id="{F2B1CD45-078B-F2F0-D972-41169DFF4C15}"/>
               </a:ext>
             </a:extLst>
           </p:cNvPr>
@@ -7931,7 +7920,7 @@
           <p:cNvPr id="3" name="Rectangle 2">
             <a:extLst>
               <a:ext uri="{FF2B5EF4-FFF2-40B4-BE49-F238E27FC236}">
-                <a16:creationId xmlns:a16="http://schemas.microsoft.com/office/drawing/2014/main" id="{57A5E25A-0176-5634-E25D-1C8C589F0942}"/>
+                <a16:creationId xmlns:a16="http://schemas.microsoft.com/office/drawing/2014/main" id="{7F429C4D-D05C-3E2D-D896-87C607F70746}"/>
               </a:ext>
             </a:extLst>
           </p:cNvPr>
@@ -7999,7 +7988,7 @@
           <p:cNvPr id="4" name="TextBox 3">
             <a:extLst>
               <a:ext uri="{FF2B5EF4-FFF2-40B4-BE49-F238E27FC236}">
-                <a16:creationId xmlns:a16="http://schemas.microsoft.com/office/drawing/2014/main" id="{0A144E66-5B62-F0AC-660A-D3DDF54619E2}"/>
+                <a16:creationId xmlns:a16="http://schemas.microsoft.com/office/drawing/2014/main" id="{FC527671-3BD0-0D3E-38E2-66A933195849}"/>
               </a:ext>
             </a:extLst>
           </p:cNvPr>
@@ -8045,7 +8034,7 @@
           <p:cNvPr id="5" name="TextBox 4">
             <a:extLst>
               <a:ext uri="{FF2B5EF4-FFF2-40B4-BE49-F238E27FC236}">
-                <a16:creationId xmlns:a16="http://schemas.microsoft.com/office/drawing/2014/main" id="{C996E43D-8E58-6813-7BBF-1E8270482E64}"/>
+                <a16:creationId xmlns:a16="http://schemas.microsoft.com/office/drawing/2014/main" id="{87FCD439-9A92-BF40-4D32-43AEE2A8B97B}"/>
               </a:ext>
             </a:extLst>
           </p:cNvPr>
@@ -8075,7 +8064,7 @@
                 </a:solidFill>
                 <a:latin typeface="Segoe UI" panose="020B0502040204020203" pitchFamily="34" charset="0"/>
               </a:rPr>
-              <a:t>Owner: Devansh Maini | Branch: feature/member3-database-security</a:t>
+              <a:t>Owner: Vaibhav Tank | Branch: feature/member3-database-security</a:t>
             </a:r>
             <a:endParaRPr lang="en-IN" sz="1300">
               <a:solidFill>
@@ -8091,7 +8080,7 @@
           <p:cNvPr id="6" name="TextBox 5">
             <a:extLst>
               <a:ext uri="{FF2B5EF4-FFF2-40B4-BE49-F238E27FC236}">
-                <a16:creationId xmlns:a16="http://schemas.microsoft.com/office/drawing/2014/main" id="{36A71E64-2CC8-2467-2D7D-E50FE380BB4F}"/>
+                <a16:creationId xmlns:a16="http://schemas.microsoft.com/office/drawing/2014/main" id="{E5178EA6-ACF4-6F2B-9004-73BA20962241}"/>
               </a:ext>
             </a:extLst>
           </p:cNvPr>
@@ -8121,7 +8110,7 @@
                 </a:solidFill>
                 <a:latin typeface="Segoe UI" panose="020B0502040204020203" pitchFamily="34" charset="0"/>
               </a:rPr>
-              <a:t>Speaker: Devansh Maini</a:t>
+              <a:t>Speaker: Vaibhav Tank</a:t>
             </a:r>
           </a:p>
         </p:txBody>
@@ -8131,7 +8120,7 @@
           <p:cNvPr id="7" name="TextBox 6">
             <a:extLst>
               <a:ext uri="{FF2B5EF4-FFF2-40B4-BE49-F238E27FC236}">
-                <a16:creationId xmlns:a16="http://schemas.microsoft.com/office/drawing/2014/main" id="{76659B92-C1B4-2ADF-39D9-94F33DF8DD26}"/>
+                <a16:creationId xmlns:a16="http://schemas.microsoft.com/office/drawing/2014/main" id="{CB862943-5026-0EC7-F25B-43EE464866F1}"/>
               </a:ext>
             </a:extLst>
           </p:cNvPr>
@@ -8175,7 +8164,7 @@
           <p:cNvPr id="8" name="TextBox 7">
             <a:extLst>
               <a:ext uri="{FF2B5EF4-FFF2-40B4-BE49-F238E27FC236}">
-                <a16:creationId xmlns:a16="http://schemas.microsoft.com/office/drawing/2014/main" id="{057110D0-89E1-2413-8C67-7B2810D3158E}"/>
+                <a16:creationId xmlns:a16="http://schemas.microsoft.com/office/drawing/2014/main" id="{DBA7D16F-674F-FEFC-A082-0B584926DDD5}"/>
               </a:ext>
             </a:extLst>
           </p:cNvPr>
@@ -8213,7 +8202,7 @@
     </p:spTree>
     <p:extLst>
       <p:ext uri="{BB962C8B-B14F-4D97-AF65-F5344CB8AC3E}">
-        <p14:creationId xmlns:p14="http://schemas.microsoft.com/office/powerpoint/2010/main" val="1490754823"/>
+        <p14:creationId xmlns:p14="http://schemas.microsoft.com/office/powerpoint/2010/main" val="3321140429"/>
       </p:ext>
     </p:extLst>
   </p:cSld>
@@ -8245,7 +8234,7 @@
           <p:cNvPr id="2" name="Rectangle 1">
             <a:extLst>
               <a:ext uri="{FF2B5EF4-FFF2-40B4-BE49-F238E27FC236}">
-                <a16:creationId xmlns:a16="http://schemas.microsoft.com/office/drawing/2014/main" id="{407000E4-9B77-E9BC-44EE-8CAA15F0A0D6}"/>
+                <a16:creationId xmlns:a16="http://schemas.microsoft.com/office/drawing/2014/main" id="{C26A21FB-DB85-90D9-5D99-6D44BE233A18}"/>
               </a:ext>
             </a:extLst>
           </p:cNvPr>
@@ -8313,7 +8302,7 @@
           <p:cNvPr id="3" name="Rectangle 2">
             <a:extLst>
               <a:ext uri="{FF2B5EF4-FFF2-40B4-BE49-F238E27FC236}">
-                <a16:creationId xmlns:a16="http://schemas.microsoft.com/office/drawing/2014/main" id="{103AFB6E-EC6B-A27E-F486-3BAA839EB0C9}"/>
+                <a16:creationId xmlns:a16="http://schemas.microsoft.com/office/drawing/2014/main" id="{EFE0D24F-9BE4-621A-EF25-CC876F8EABBA}"/>
               </a:ext>
             </a:extLst>
           </p:cNvPr>
@@ -8381,7 +8370,7 @@
           <p:cNvPr id="4" name="TextBox 3">
             <a:extLst>
               <a:ext uri="{FF2B5EF4-FFF2-40B4-BE49-F238E27FC236}">
-                <a16:creationId xmlns:a16="http://schemas.microsoft.com/office/drawing/2014/main" id="{DFDED343-8548-E8F6-1AFA-B88ECAA3A1AD}"/>
+                <a16:creationId xmlns:a16="http://schemas.microsoft.com/office/drawing/2014/main" id="{3FD4C9AD-17BB-6EDF-87EC-F830522885AD}"/>
               </a:ext>
             </a:extLst>
           </p:cNvPr>
@@ -8427,7 +8416,7 @@
           <p:cNvPr id="5" name="TextBox 4">
             <a:extLst>
               <a:ext uri="{FF2B5EF4-FFF2-40B4-BE49-F238E27FC236}">
-                <a16:creationId xmlns:a16="http://schemas.microsoft.com/office/drawing/2014/main" id="{1C3894AA-D5F6-4CA5-9379-CAC3E6843FC2}"/>
+                <a16:creationId xmlns:a16="http://schemas.microsoft.com/office/drawing/2014/main" id="{A3EF427A-114B-0AFF-3A29-EDB01EE03887}"/>
               </a:ext>
             </a:extLst>
           </p:cNvPr>
@@ -8457,7 +8446,7 @@
                 </a:solidFill>
                 <a:latin typeface="Segoe UI" panose="020B0502040204020203" pitchFamily="34" charset="0"/>
               </a:rPr>
-              <a:t>Owner: Aviral Joshi | Branch: feature/member4-ui-electron</a:t>
+              <a:t>Owner: Rajveer Singh Ranawat | Branch: feature/member4-ui-electron</a:t>
             </a:r>
             <a:endParaRPr lang="en-IN" sz="1300">
               <a:solidFill>
@@ -8473,7 +8462,7 @@
           <p:cNvPr id="6" name="TextBox 5">
             <a:extLst>
               <a:ext uri="{FF2B5EF4-FFF2-40B4-BE49-F238E27FC236}">
-                <a16:creationId xmlns:a16="http://schemas.microsoft.com/office/drawing/2014/main" id="{92EA4D2E-C90F-9986-4DFF-2D270660C826}"/>
+                <a16:creationId xmlns:a16="http://schemas.microsoft.com/office/drawing/2014/main" id="{8B1184AB-D9F2-8E03-F153-C5CD36D69D7D}"/>
               </a:ext>
             </a:extLst>
           </p:cNvPr>
@@ -8503,7 +8492,7 @@
                 </a:solidFill>
                 <a:latin typeface="Segoe UI" panose="020B0502040204020203" pitchFamily="34" charset="0"/>
               </a:rPr>
-              <a:t>Speaker: Aviral Joshi</a:t>
+              <a:t>Speaker: Rajveer Singh Ranawat</a:t>
             </a:r>
           </a:p>
         </p:txBody>
@@ -8513,7 +8502,7 @@
           <p:cNvPr id="7" name="TextBox 6">
             <a:extLst>
               <a:ext uri="{FF2B5EF4-FFF2-40B4-BE49-F238E27FC236}">
-                <a16:creationId xmlns:a16="http://schemas.microsoft.com/office/drawing/2014/main" id="{F27AE4A4-5C51-C39E-D237-78FE3E28DCF5}"/>
+                <a16:creationId xmlns:a16="http://schemas.microsoft.com/office/drawing/2014/main" id="{9967705F-86ED-373C-8345-8125B498EC03}"/>
               </a:ext>
             </a:extLst>
           </p:cNvPr>
@@ -8557,7 +8546,7 @@
           <p:cNvPr id="8" name="TextBox 7">
             <a:extLst>
               <a:ext uri="{FF2B5EF4-FFF2-40B4-BE49-F238E27FC236}">
-                <a16:creationId xmlns:a16="http://schemas.microsoft.com/office/drawing/2014/main" id="{FBC6495C-E4B8-637D-D869-FE042FF59A9F}"/>
+                <a16:creationId xmlns:a16="http://schemas.microsoft.com/office/drawing/2014/main" id="{92024100-80CD-0D4B-1571-BEA8B4567B25}"/>
               </a:ext>
             </a:extLst>
           </p:cNvPr>
@@ -8595,7 +8584,7 @@
     </p:spTree>
     <p:extLst>
       <p:ext uri="{BB962C8B-B14F-4D97-AF65-F5344CB8AC3E}">
-        <p14:creationId xmlns:p14="http://schemas.microsoft.com/office/powerpoint/2010/main" val="1472101780"/>
+        <p14:creationId xmlns:p14="http://schemas.microsoft.com/office/powerpoint/2010/main" val="3907553898"/>
       </p:ext>
     </p:extLst>
   </p:cSld>
@@ -8627,7 +8616,7 @@
           <p:cNvPr id="2" name="Rectangle 1">
             <a:extLst>
               <a:ext uri="{FF2B5EF4-FFF2-40B4-BE49-F238E27FC236}">
-                <a16:creationId xmlns:a16="http://schemas.microsoft.com/office/drawing/2014/main" id="{B43DDF23-76A6-7AE8-1992-AECB4B22B89D}"/>
+                <a16:creationId xmlns:a16="http://schemas.microsoft.com/office/drawing/2014/main" id="{B144373D-8991-DE2B-995A-B476FD388C3A}"/>
               </a:ext>
             </a:extLst>
           </p:cNvPr>
@@ -8695,7 +8684,7 @@
           <p:cNvPr id="3" name="Rectangle 2">
             <a:extLst>
               <a:ext uri="{FF2B5EF4-FFF2-40B4-BE49-F238E27FC236}">
-                <a16:creationId xmlns:a16="http://schemas.microsoft.com/office/drawing/2014/main" id="{653B4EB3-193B-B173-0EDD-34221BBCDAD4}"/>
+                <a16:creationId xmlns:a16="http://schemas.microsoft.com/office/drawing/2014/main" id="{B0ACEF19-7A84-8FF9-35F9-890EFC59DF66}"/>
               </a:ext>
             </a:extLst>
           </p:cNvPr>
@@ -8763,7 +8752,7 @@
           <p:cNvPr id="4" name="TextBox 3">
             <a:extLst>
               <a:ext uri="{FF2B5EF4-FFF2-40B4-BE49-F238E27FC236}">
-                <a16:creationId xmlns:a16="http://schemas.microsoft.com/office/drawing/2014/main" id="{85B2033A-EE0D-DF88-E86F-7C49B6DFC0FC}"/>
+                <a16:creationId xmlns:a16="http://schemas.microsoft.com/office/drawing/2014/main" id="{E2EDE9DB-484F-E2E0-5CEE-3B1D4D539CF8}"/>
               </a:ext>
             </a:extLst>
           </p:cNvPr>
@@ -8809,7 +8798,7 @@
           <p:cNvPr id="5" name="TextBox 4">
             <a:extLst>
               <a:ext uri="{FF2B5EF4-FFF2-40B4-BE49-F238E27FC236}">
-                <a16:creationId xmlns:a16="http://schemas.microsoft.com/office/drawing/2014/main" id="{8300B094-2B55-F66A-F39D-2E692D5C6E28}"/>
+                <a16:creationId xmlns:a16="http://schemas.microsoft.com/office/drawing/2014/main" id="{99F39319-69DA-261F-5E8E-78A614710452}"/>
               </a:ext>
             </a:extLst>
           </p:cNvPr>
@@ -8839,7 +8828,7 @@
                 </a:solidFill>
                 <a:latin typeface="Segoe UI" panose="020B0502040204020203" pitchFamily="34" charset="0"/>
               </a:rPr>
-              <a:t>Owner: Akshita Mawaliya | Branch: feature/member5-analytics-evaluation</a:t>
+              <a:t>Owner: Yashpal Singh Bhati | Branch: feature/member5-analytics-evaluation</a:t>
             </a:r>
             <a:endParaRPr lang="en-IN" sz="1300">
               <a:solidFill>
@@ -8855,7 +8844,7 @@
           <p:cNvPr id="6" name="TextBox 5">
             <a:extLst>
               <a:ext uri="{FF2B5EF4-FFF2-40B4-BE49-F238E27FC236}">
-                <a16:creationId xmlns:a16="http://schemas.microsoft.com/office/drawing/2014/main" id="{33ECA955-9B0E-6239-A1F0-C188F39B768E}"/>
+                <a16:creationId xmlns:a16="http://schemas.microsoft.com/office/drawing/2014/main" id="{8F4C6968-8BE3-AD5B-5055-CC0A841AD095}"/>
               </a:ext>
             </a:extLst>
           </p:cNvPr>
@@ -8885,7 +8874,7 @@
                 </a:solidFill>
                 <a:latin typeface="Segoe UI" panose="020B0502040204020203" pitchFamily="34" charset="0"/>
               </a:rPr>
-              <a:t>Speaker: Akshita Mawaliya</a:t>
+              <a:t>Speaker: Yashpal Singh Bhati</a:t>
             </a:r>
           </a:p>
         </p:txBody>
@@ -8895,7 +8884,7 @@
           <p:cNvPr id="7" name="TextBox 6">
             <a:extLst>
               <a:ext uri="{FF2B5EF4-FFF2-40B4-BE49-F238E27FC236}">
-                <a16:creationId xmlns:a16="http://schemas.microsoft.com/office/drawing/2014/main" id="{BFEDBD6E-6507-6980-FD49-FF3EBA3A363A}"/>
+                <a16:creationId xmlns:a16="http://schemas.microsoft.com/office/drawing/2014/main" id="{36691FBE-1477-968E-421D-F2F5EE621041}"/>
               </a:ext>
             </a:extLst>
           </p:cNvPr>
@@ -8928,7 +8917,7 @@
               <a:t>[*]  RAG Triad Metrics: Context Relevance, Groundedness (Faithfulness), and Answer Relevance.
 [*]  Admin Telemetry Dashboard: Recharts visualization of query volume, latency histograms, and index size.
 [*]  Automated Testing Suite: JUnit 5 and Mockito test cases achieving 84.6% branch coverage.
-[*]  Golden Dataset Benchmark: 50 ground-truth academic Q&amp;A pairs evaluated continuously.
+[*]  Golden Dataset Benchmark: 50 ground-truth academic Q&amp;A pairs evaluated continuously against Kaggle dataset.
 [*]  Hallucination Auditing: Tracks factual consistency and logs low-confidence queries.</a:t>
             </a:r>
           </a:p>
@@ -8939,7 +8928,7 @@
           <p:cNvPr id="8" name="TextBox 7">
             <a:extLst>
               <a:ext uri="{FF2B5EF4-FFF2-40B4-BE49-F238E27FC236}">
-                <a16:creationId xmlns:a16="http://schemas.microsoft.com/office/drawing/2014/main" id="{00A98CFA-D67B-1F2C-EF24-AF37E9C84CD0}"/>
+                <a16:creationId xmlns:a16="http://schemas.microsoft.com/office/drawing/2014/main" id="{5D561B75-52F6-4EA2-0773-21B34B7F4B69}"/>
               </a:ext>
             </a:extLst>
           </p:cNvPr>
@@ -8977,7 +8966,7 @@
     </p:spTree>
     <p:extLst>
       <p:ext uri="{BB962C8B-B14F-4D97-AF65-F5344CB8AC3E}">
-        <p14:creationId xmlns:p14="http://schemas.microsoft.com/office/powerpoint/2010/main" val="4183036714"/>
+        <p14:creationId xmlns:p14="http://schemas.microsoft.com/office/powerpoint/2010/main" val="1093844410"/>
       </p:ext>
     </p:extLst>
   </p:cSld>

</xml_diff>